<commit_message>
uniforming fonts up to lesson 17
</commit_message>
<xml_diff>
--- a/lesson_05-the_flutter_framework/lesson_05-the_flutter_framework.pptx
+++ b/lesson_05-the_flutter_framework/lesson_05-the_flutter_framework.pptx
@@ -232,7 +232,7 @@
           <a:p>
             <a:fld id="{81C4B3FE-0320-8142-8396-5C3025C019EC}" type="datetimeFigureOut">
               <a:rPr lang="en-IT" smtClean="0"/>
-              <a:t>2/11/26</a:t>
+              <a:t>2/19/26</a:t>
             </a:fld>
             <a:endParaRPr lang="en-IT"/>
           </a:p>
@@ -5214,42 +5214,56 @@
           <a:p>
             <a:r>
               <a:rPr lang="en-GB" sz="1600" dirty="0">
-                <a:latin typeface="Courier" pitchFamily="2" charset="0"/>
+                <a:latin typeface="Menlo" panose="020B0609030804020204" pitchFamily="49" charset="0"/>
+                <a:ea typeface="Menlo" panose="020B0609030804020204" pitchFamily="49" charset="0"/>
+                <a:cs typeface="Menlo" panose="020B0609030804020204" pitchFamily="49" charset="0"/>
               </a:rPr>
               <a:t>import '</a:t>
             </a:r>
             <a:r>
               <a:rPr lang="en-GB" sz="1600" dirty="0" err="1">
-                <a:latin typeface="Courier" pitchFamily="2" charset="0"/>
+                <a:latin typeface="Menlo" panose="020B0609030804020204" pitchFamily="49" charset="0"/>
+                <a:ea typeface="Menlo" panose="020B0609030804020204" pitchFamily="49" charset="0"/>
+                <a:cs typeface="Menlo" panose="020B0609030804020204" pitchFamily="49" charset="0"/>
               </a:rPr>
               <a:t>package:flutter</a:t>
             </a:r>
             <a:r>
               <a:rPr lang="en-GB" sz="1600" dirty="0">
-                <a:latin typeface="Courier" pitchFamily="2" charset="0"/>
+                <a:latin typeface="Menlo" panose="020B0609030804020204" pitchFamily="49" charset="0"/>
+                <a:ea typeface="Menlo" panose="020B0609030804020204" pitchFamily="49" charset="0"/>
+                <a:cs typeface="Menlo" panose="020B0609030804020204" pitchFamily="49" charset="0"/>
               </a:rPr>
               <a:t>/</a:t>
             </a:r>
             <a:r>
               <a:rPr lang="en-GB" sz="1600" dirty="0" err="1">
-                <a:latin typeface="Courier" pitchFamily="2" charset="0"/>
+                <a:latin typeface="Menlo" panose="020B0609030804020204" pitchFamily="49" charset="0"/>
+                <a:ea typeface="Menlo" panose="020B0609030804020204" pitchFamily="49" charset="0"/>
+                <a:cs typeface="Menlo" panose="020B0609030804020204" pitchFamily="49" charset="0"/>
               </a:rPr>
               <a:t>material.dart</a:t>
             </a:r>
             <a:r>
               <a:rPr lang="en-GB" sz="1600" dirty="0">
-                <a:latin typeface="Courier" pitchFamily="2" charset="0"/>
+                <a:latin typeface="Menlo" panose="020B0609030804020204" pitchFamily="49" charset="0"/>
+                <a:ea typeface="Menlo" panose="020B0609030804020204" pitchFamily="49" charset="0"/>
+                <a:cs typeface="Menlo" panose="020B0609030804020204" pitchFamily="49" charset="0"/>
               </a:rPr>
               <a:t>';</a:t>
             </a:r>
             <a:br>
               <a:rPr lang="en-GB" sz="1600" dirty="0">
-                <a:latin typeface="Courier" pitchFamily="2" charset="0"/>
+                <a:latin typeface="Menlo" panose="020B0609030804020204" pitchFamily="49" charset="0"/>
+                <a:ea typeface="Menlo" panose="020B0609030804020204" pitchFamily="49" charset="0"/>
+                <a:cs typeface="Menlo" panose="020B0609030804020204" pitchFamily="49" charset="0"/>
               </a:rPr>
             </a:br>
             <a:r>
               <a:rPr lang="en-GB" sz="1600" dirty="0">
-                <a:latin typeface="Courier" pitchFamily="2" charset="0"/>
+                <a:latin typeface="Menlo" panose="020B0609030804020204" pitchFamily="49" charset="0"/>
+                <a:ea typeface="Menlo" panose="020B0609030804020204" pitchFamily="49" charset="0"/>
+                <a:cs typeface="Menlo" panose="020B0609030804020204" pitchFamily="49" charset="0"/>
               </a:rPr>
               <a:t>void main() {</a:t>
             </a:r>
@@ -5257,31 +5271,41 @@
           <a:p>
             <a:r>
               <a:rPr lang="en-GB" sz="1600" dirty="0">
-                <a:latin typeface="Courier" pitchFamily="2" charset="0"/>
+                <a:latin typeface="Menlo" panose="020B0609030804020204" pitchFamily="49" charset="0"/>
+                <a:ea typeface="Menlo" panose="020B0609030804020204" pitchFamily="49" charset="0"/>
+                <a:cs typeface="Menlo" panose="020B0609030804020204" pitchFamily="49" charset="0"/>
               </a:rPr>
               <a:t>  </a:t>
             </a:r>
             <a:r>
               <a:rPr lang="en-GB" sz="1600" dirty="0" err="1">
-                <a:latin typeface="Courier" pitchFamily="2" charset="0"/>
+                <a:latin typeface="Menlo" panose="020B0609030804020204" pitchFamily="49" charset="0"/>
+                <a:ea typeface="Menlo" panose="020B0609030804020204" pitchFamily="49" charset="0"/>
+                <a:cs typeface="Menlo" panose="020B0609030804020204" pitchFamily="49" charset="0"/>
               </a:rPr>
               <a:t>runApp</a:t>
             </a:r>
             <a:r>
               <a:rPr lang="en-GB" sz="1600" dirty="0">
-                <a:latin typeface="Courier" pitchFamily="2" charset="0"/>
+                <a:latin typeface="Menlo" panose="020B0609030804020204" pitchFamily="49" charset="0"/>
+                <a:ea typeface="Menlo" panose="020B0609030804020204" pitchFamily="49" charset="0"/>
+                <a:cs typeface="Menlo" panose="020B0609030804020204" pitchFamily="49" charset="0"/>
               </a:rPr>
               <a:t>(</a:t>
             </a:r>
             <a:r>
               <a:rPr lang="en-GB" sz="1600" dirty="0" err="1">
-                <a:latin typeface="Courier" pitchFamily="2" charset="0"/>
+                <a:latin typeface="Menlo" panose="020B0609030804020204" pitchFamily="49" charset="0"/>
+                <a:ea typeface="Menlo" panose="020B0609030804020204" pitchFamily="49" charset="0"/>
+                <a:cs typeface="Menlo" panose="020B0609030804020204" pitchFamily="49" charset="0"/>
               </a:rPr>
               <a:t>MyApp</a:t>
             </a:r>
             <a:r>
               <a:rPr lang="en-GB" sz="1600" dirty="0">
-                <a:latin typeface="Courier" pitchFamily="2" charset="0"/>
+                <a:latin typeface="Menlo" panose="020B0609030804020204" pitchFamily="49" charset="0"/>
+                <a:ea typeface="Menlo" panose="020B0609030804020204" pitchFamily="49" charset="0"/>
+                <a:cs typeface="Menlo" panose="020B0609030804020204" pitchFamily="49" charset="0"/>
               </a:rPr>
               <a:t>());</a:t>
             </a:r>
@@ -5289,42 +5313,56 @@
           <a:p>
             <a:r>
               <a:rPr lang="en-GB" sz="1600" dirty="0">
-                <a:latin typeface="Courier" pitchFamily="2" charset="0"/>
+                <a:latin typeface="Menlo" panose="020B0609030804020204" pitchFamily="49" charset="0"/>
+                <a:ea typeface="Menlo" panose="020B0609030804020204" pitchFamily="49" charset="0"/>
+                <a:cs typeface="Menlo" panose="020B0609030804020204" pitchFamily="49" charset="0"/>
               </a:rPr>
               <a:t>}//main</a:t>
             </a:r>
             <a:br>
               <a:rPr lang="en-GB" sz="1600" dirty="0">
-                <a:latin typeface="Courier" pitchFamily="2" charset="0"/>
+                <a:latin typeface="Menlo" panose="020B0609030804020204" pitchFamily="49" charset="0"/>
+                <a:ea typeface="Menlo" panose="020B0609030804020204" pitchFamily="49" charset="0"/>
+                <a:cs typeface="Menlo" panose="020B0609030804020204" pitchFamily="49" charset="0"/>
               </a:rPr>
             </a:br>
             <a:r>
               <a:rPr lang="en-GB" sz="1600" dirty="0">
-                <a:latin typeface="Courier" pitchFamily="2" charset="0"/>
+                <a:latin typeface="Menlo" panose="020B0609030804020204" pitchFamily="49" charset="0"/>
+                <a:ea typeface="Menlo" panose="020B0609030804020204" pitchFamily="49" charset="0"/>
+                <a:cs typeface="Menlo" panose="020B0609030804020204" pitchFamily="49" charset="0"/>
               </a:rPr>
               <a:t>class </a:t>
             </a:r>
             <a:r>
               <a:rPr lang="en-GB" sz="1600" dirty="0" err="1">
-                <a:latin typeface="Courier" pitchFamily="2" charset="0"/>
+                <a:latin typeface="Menlo" panose="020B0609030804020204" pitchFamily="49" charset="0"/>
+                <a:ea typeface="Menlo" panose="020B0609030804020204" pitchFamily="49" charset="0"/>
+                <a:cs typeface="Menlo" panose="020B0609030804020204" pitchFamily="49" charset="0"/>
               </a:rPr>
               <a:t>MyApp</a:t>
             </a:r>
             <a:r>
               <a:rPr lang="en-GB" sz="1600" dirty="0">
-                <a:latin typeface="Courier" pitchFamily="2" charset="0"/>
+                <a:latin typeface="Menlo" panose="020B0609030804020204" pitchFamily="49" charset="0"/>
+                <a:ea typeface="Menlo" panose="020B0609030804020204" pitchFamily="49" charset="0"/>
+                <a:cs typeface="Menlo" panose="020B0609030804020204" pitchFamily="49" charset="0"/>
               </a:rPr>
               <a:t> extends </a:t>
             </a:r>
             <a:r>
               <a:rPr lang="en-GB" sz="1600" dirty="0" err="1">
-                <a:latin typeface="Courier" pitchFamily="2" charset="0"/>
+                <a:latin typeface="Menlo" panose="020B0609030804020204" pitchFamily="49" charset="0"/>
+                <a:ea typeface="Menlo" panose="020B0609030804020204" pitchFamily="49" charset="0"/>
+                <a:cs typeface="Menlo" panose="020B0609030804020204" pitchFamily="49" charset="0"/>
               </a:rPr>
               <a:t>StatelessWidget</a:t>
             </a:r>
             <a:r>
               <a:rPr lang="en-GB" sz="1600" dirty="0">
-                <a:latin typeface="Courier" pitchFamily="2" charset="0"/>
+                <a:latin typeface="Menlo" panose="020B0609030804020204" pitchFamily="49" charset="0"/>
+                <a:ea typeface="Menlo" panose="020B0609030804020204" pitchFamily="49" charset="0"/>
+                <a:cs typeface="Menlo" panose="020B0609030804020204" pitchFamily="49" charset="0"/>
               </a:rPr>
               <a:t> {</a:t>
             </a:r>
@@ -5332,19 +5370,25 @@
           <a:p>
             <a:r>
               <a:rPr lang="en-GB" sz="1600" dirty="0">
-                <a:latin typeface="Courier" pitchFamily="2" charset="0"/>
+                <a:latin typeface="Menlo" panose="020B0609030804020204" pitchFamily="49" charset="0"/>
+                <a:ea typeface="Menlo" panose="020B0609030804020204" pitchFamily="49" charset="0"/>
+                <a:cs typeface="Menlo" panose="020B0609030804020204" pitchFamily="49" charset="0"/>
               </a:rPr>
               <a:t>  </a:t>
             </a:r>
             <a:r>
               <a:rPr lang="en-GB" sz="1600" dirty="0" err="1">
-                <a:latin typeface="Courier" pitchFamily="2" charset="0"/>
+                <a:latin typeface="Menlo" panose="020B0609030804020204" pitchFamily="49" charset="0"/>
+                <a:ea typeface="Menlo" panose="020B0609030804020204" pitchFamily="49" charset="0"/>
+                <a:cs typeface="Menlo" panose="020B0609030804020204" pitchFamily="49" charset="0"/>
               </a:rPr>
               <a:t>MyApp</a:t>
             </a:r>
             <a:r>
               <a:rPr lang="en-GB" sz="1600" dirty="0">
-                <a:latin typeface="Courier" pitchFamily="2" charset="0"/>
+                <a:latin typeface="Menlo" panose="020B0609030804020204" pitchFamily="49" charset="0"/>
+                <a:ea typeface="Menlo" panose="020B0609030804020204" pitchFamily="49" charset="0"/>
+                <a:cs typeface="Menlo" panose="020B0609030804020204" pitchFamily="49" charset="0"/>
               </a:rPr>
               <a:t>({Key? key}) : super(key: key);</a:t>
             </a:r>
@@ -5352,12 +5396,16 @@
           <a:p>
             <a:br>
               <a:rPr lang="en-GB" sz="1600" dirty="0">
-                <a:latin typeface="Courier" pitchFamily="2" charset="0"/>
+                <a:latin typeface="Menlo" panose="020B0609030804020204" pitchFamily="49" charset="0"/>
+                <a:ea typeface="Menlo" panose="020B0609030804020204" pitchFamily="49" charset="0"/>
+                <a:cs typeface="Menlo" panose="020B0609030804020204" pitchFamily="49" charset="0"/>
               </a:rPr>
             </a:br>
             <a:r>
               <a:rPr lang="en-GB" sz="1600" dirty="0">
-                <a:latin typeface="Courier" pitchFamily="2" charset="0"/>
+                <a:latin typeface="Menlo" panose="020B0609030804020204" pitchFamily="49" charset="0"/>
+                <a:ea typeface="Menlo" panose="020B0609030804020204" pitchFamily="49" charset="0"/>
+                <a:cs typeface="Menlo" panose="020B0609030804020204" pitchFamily="49" charset="0"/>
               </a:rPr>
               <a:t>  @override</a:t>
             </a:r>
@@ -5365,19 +5413,25 @@
           <a:p>
             <a:r>
               <a:rPr lang="en-GB" sz="1600" dirty="0">
-                <a:latin typeface="Courier" pitchFamily="2" charset="0"/>
+                <a:latin typeface="Menlo" panose="020B0609030804020204" pitchFamily="49" charset="0"/>
+                <a:ea typeface="Menlo" panose="020B0609030804020204" pitchFamily="49" charset="0"/>
+                <a:cs typeface="Menlo" panose="020B0609030804020204" pitchFamily="49" charset="0"/>
               </a:rPr>
               <a:t>  Widget build(</a:t>
             </a:r>
             <a:r>
               <a:rPr lang="en-GB" sz="1600" dirty="0" err="1">
-                <a:latin typeface="Courier" pitchFamily="2" charset="0"/>
+                <a:latin typeface="Menlo" panose="020B0609030804020204" pitchFamily="49" charset="0"/>
+                <a:ea typeface="Menlo" panose="020B0609030804020204" pitchFamily="49" charset="0"/>
+                <a:cs typeface="Menlo" panose="020B0609030804020204" pitchFamily="49" charset="0"/>
               </a:rPr>
               <a:t>BuildContext</a:t>
             </a:r>
             <a:r>
               <a:rPr lang="en-GB" sz="1600" dirty="0">
-                <a:latin typeface="Courier" pitchFamily="2" charset="0"/>
+                <a:latin typeface="Menlo" panose="020B0609030804020204" pitchFamily="49" charset="0"/>
+                <a:ea typeface="Menlo" panose="020B0609030804020204" pitchFamily="49" charset="0"/>
+                <a:cs typeface="Menlo" panose="020B0609030804020204" pitchFamily="49" charset="0"/>
               </a:rPr>
               <a:t> context) {</a:t>
             </a:r>
@@ -5385,19 +5439,25 @@
           <a:p>
             <a:r>
               <a:rPr lang="en-GB" sz="1600" dirty="0">
-                <a:latin typeface="Courier" pitchFamily="2" charset="0"/>
+                <a:latin typeface="Menlo" panose="020B0609030804020204" pitchFamily="49" charset="0"/>
+                <a:ea typeface="Menlo" panose="020B0609030804020204" pitchFamily="49" charset="0"/>
+                <a:cs typeface="Menlo" panose="020B0609030804020204" pitchFamily="49" charset="0"/>
               </a:rPr>
               <a:t>    return </a:t>
             </a:r>
             <a:r>
               <a:rPr lang="en-GB" sz="1600" dirty="0" err="1">
-                <a:latin typeface="Courier" pitchFamily="2" charset="0"/>
+                <a:latin typeface="Menlo" panose="020B0609030804020204" pitchFamily="49" charset="0"/>
+                <a:ea typeface="Menlo" panose="020B0609030804020204" pitchFamily="49" charset="0"/>
+                <a:cs typeface="Menlo" panose="020B0609030804020204" pitchFamily="49" charset="0"/>
               </a:rPr>
               <a:t>MaterialApp</a:t>
             </a:r>
             <a:r>
               <a:rPr lang="en-GB" sz="1600" dirty="0">
-                <a:latin typeface="Courier" pitchFamily="2" charset="0"/>
+                <a:latin typeface="Menlo" panose="020B0609030804020204" pitchFamily="49" charset="0"/>
+                <a:ea typeface="Menlo" panose="020B0609030804020204" pitchFamily="49" charset="0"/>
+                <a:cs typeface="Menlo" panose="020B0609030804020204" pitchFamily="49" charset="0"/>
               </a:rPr>
               <a:t>(</a:t>
             </a:r>
@@ -5405,7 +5465,9 @@
           <a:p>
             <a:r>
               <a:rPr lang="en-GB" sz="1600" dirty="0">
-                <a:latin typeface="Courier" pitchFamily="2" charset="0"/>
+                <a:latin typeface="Menlo" panose="020B0609030804020204" pitchFamily="49" charset="0"/>
+                <a:ea typeface="Menlo" panose="020B0609030804020204" pitchFamily="49" charset="0"/>
+                <a:cs typeface="Menlo" panose="020B0609030804020204" pitchFamily="49" charset="0"/>
               </a:rPr>
               <a:t>      title: 'Welcome to Flutter’,</a:t>
             </a:r>
@@ -5413,7 +5475,9 @@
           <a:p>
             <a:r>
               <a:rPr lang="en-GB" sz="1600" dirty="0">
-                <a:latin typeface="Courier" pitchFamily="2" charset="0"/>
+                <a:latin typeface="Menlo" panose="020B0609030804020204" pitchFamily="49" charset="0"/>
+                <a:ea typeface="Menlo" panose="020B0609030804020204" pitchFamily="49" charset="0"/>
+                <a:cs typeface="Menlo" panose="020B0609030804020204" pitchFamily="49" charset="0"/>
               </a:rPr>
               <a:t>      home: Scaffold(</a:t>
             </a:r>
@@ -5421,31 +5485,41 @@
           <a:p>
             <a:r>
               <a:rPr lang="en-GB" sz="1600" dirty="0">
-                <a:latin typeface="Courier" pitchFamily="2" charset="0"/>
+                <a:latin typeface="Menlo" panose="020B0609030804020204" pitchFamily="49" charset="0"/>
+                <a:ea typeface="Menlo" panose="020B0609030804020204" pitchFamily="49" charset="0"/>
+                <a:cs typeface="Menlo" panose="020B0609030804020204" pitchFamily="49" charset="0"/>
               </a:rPr>
               <a:t>      </a:t>
             </a:r>
             <a:r>
               <a:rPr lang="en-GB" sz="1600" dirty="0" err="1">
-                <a:latin typeface="Courier" pitchFamily="2" charset="0"/>
+                <a:latin typeface="Menlo" panose="020B0609030804020204" pitchFamily="49" charset="0"/>
+                <a:ea typeface="Menlo" panose="020B0609030804020204" pitchFamily="49" charset="0"/>
+                <a:cs typeface="Menlo" panose="020B0609030804020204" pitchFamily="49" charset="0"/>
               </a:rPr>
               <a:t>appBar</a:t>
             </a:r>
             <a:r>
               <a:rPr lang="en-GB" sz="1600" dirty="0">
-                <a:latin typeface="Courier" pitchFamily="2" charset="0"/>
+                <a:latin typeface="Menlo" panose="020B0609030804020204" pitchFamily="49" charset="0"/>
+                <a:ea typeface="Menlo" panose="020B0609030804020204" pitchFamily="49" charset="0"/>
+                <a:cs typeface="Menlo" panose="020B0609030804020204" pitchFamily="49" charset="0"/>
               </a:rPr>
               <a:t>: </a:t>
             </a:r>
             <a:r>
               <a:rPr lang="en-GB" sz="1600" dirty="0" err="1">
-                <a:latin typeface="Courier" pitchFamily="2" charset="0"/>
+                <a:latin typeface="Menlo" panose="020B0609030804020204" pitchFamily="49" charset="0"/>
+                <a:ea typeface="Menlo" panose="020B0609030804020204" pitchFamily="49" charset="0"/>
+                <a:cs typeface="Menlo" panose="020B0609030804020204" pitchFamily="49" charset="0"/>
               </a:rPr>
               <a:t>AppBar</a:t>
             </a:r>
             <a:r>
               <a:rPr lang="en-GB" sz="1600" dirty="0">
-                <a:latin typeface="Courier" pitchFamily="2" charset="0"/>
+                <a:latin typeface="Menlo" panose="020B0609030804020204" pitchFamily="49" charset="0"/>
+                <a:ea typeface="Menlo" panose="020B0609030804020204" pitchFamily="49" charset="0"/>
+                <a:cs typeface="Menlo" panose="020B0609030804020204" pitchFamily="49" charset="0"/>
               </a:rPr>
               <a:t>(title: Text('Welcome to Flutter'),),</a:t>
             </a:r>
@@ -5453,19 +5527,25 @@
           <a:p>
             <a:r>
               <a:rPr lang="en-GB" sz="1600" dirty="0">
-                <a:latin typeface="Courier" pitchFamily="2" charset="0"/>
+                <a:latin typeface="Menlo" panose="020B0609030804020204" pitchFamily="49" charset="0"/>
+                <a:ea typeface="Menlo" panose="020B0609030804020204" pitchFamily="49" charset="0"/>
+                <a:cs typeface="Menlo" panose="020B0609030804020204" pitchFamily="49" charset="0"/>
               </a:rPr>
               <a:t>      body: </a:t>
             </a:r>
             <a:r>
               <a:rPr lang="en-GB" sz="1600" dirty="0" err="1">
-                <a:latin typeface="Courier" pitchFamily="2" charset="0"/>
+                <a:latin typeface="Menlo" panose="020B0609030804020204" pitchFamily="49" charset="0"/>
+                <a:ea typeface="Menlo" panose="020B0609030804020204" pitchFamily="49" charset="0"/>
+                <a:cs typeface="Menlo" panose="020B0609030804020204" pitchFamily="49" charset="0"/>
               </a:rPr>
               <a:t>Center</a:t>
             </a:r>
             <a:r>
               <a:rPr lang="en-GB" sz="1600" dirty="0">
-                <a:latin typeface="Courier" pitchFamily="2" charset="0"/>
+                <a:latin typeface="Menlo" panose="020B0609030804020204" pitchFamily="49" charset="0"/>
+                <a:ea typeface="Menlo" panose="020B0609030804020204" pitchFamily="49" charset="0"/>
+                <a:cs typeface="Menlo" panose="020B0609030804020204" pitchFamily="49" charset="0"/>
               </a:rPr>
               <a:t>(child: Text('Hello World'),),),</a:t>
             </a:r>
@@ -5473,7 +5553,9 @@
           <a:p>
             <a:r>
               <a:rPr lang="en-GB" sz="1600" dirty="0">
-                <a:latin typeface="Courier" pitchFamily="2" charset="0"/>
+                <a:latin typeface="Menlo" panose="020B0609030804020204" pitchFamily="49" charset="0"/>
+                <a:ea typeface="Menlo" panose="020B0609030804020204" pitchFamily="49" charset="0"/>
+                <a:cs typeface="Menlo" panose="020B0609030804020204" pitchFamily="49" charset="0"/>
               </a:rPr>
               <a:t>    );</a:t>
             </a:r>
@@ -5481,7 +5563,9 @@
           <a:p>
             <a:r>
               <a:rPr lang="en-GB" sz="1600" dirty="0">
-                <a:latin typeface="Courier" pitchFamily="2" charset="0"/>
+                <a:latin typeface="Menlo" panose="020B0609030804020204" pitchFamily="49" charset="0"/>
+                <a:ea typeface="Menlo" panose="020B0609030804020204" pitchFamily="49" charset="0"/>
+                <a:cs typeface="Menlo" panose="020B0609030804020204" pitchFamily="49" charset="0"/>
               </a:rPr>
               <a:t>  }//build</a:t>
             </a:r>
@@ -5489,18 +5573,24 @@
           <a:p>
             <a:r>
               <a:rPr lang="en-GB" sz="1600" dirty="0">
-                <a:latin typeface="Courier" pitchFamily="2" charset="0"/>
+                <a:latin typeface="Menlo" panose="020B0609030804020204" pitchFamily="49" charset="0"/>
+                <a:ea typeface="Menlo" panose="020B0609030804020204" pitchFamily="49" charset="0"/>
+                <a:cs typeface="Menlo" panose="020B0609030804020204" pitchFamily="49" charset="0"/>
               </a:rPr>
               <a:t>}//</a:t>
             </a:r>
             <a:r>
               <a:rPr lang="en-GB" sz="1600" dirty="0" err="1">
-                <a:latin typeface="Courier" pitchFamily="2" charset="0"/>
+                <a:latin typeface="Menlo" panose="020B0609030804020204" pitchFamily="49" charset="0"/>
+                <a:ea typeface="Menlo" panose="020B0609030804020204" pitchFamily="49" charset="0"/>
+                <a:cs typeface="Menlo" panose="020B0609030804020204" pitchFamily="49" charset="0"/>
               </a:rPr>
               <a:t>MyApp</a:t>
             </a:r>
             <a:endParaRPr lang="en-GB" sz="1600" dirty="0">
-              <a:latin typeface="Courier" pitchFamily="2" charset="0"/>
+              <a:latin typeface="Menlo" panose="020B0609030804020204" pitchFamily="49" charset="0"/>
+              <a:ea typeface="Menlo" panose="020B0609030804020204" pitchFamily="49" charset="0"/>
+              <a:cs typeface="Menlo" panose="020B0609030804020204" pitchFamily="49" charset="0"/>
             </a:endParaRPr>
           </a:p>
         </p:txBody>
@@ -5581,8 +5671,9 @@
             </a:r>
             <a:r>
               <a:rPr lang="en-GB" b="1" dirty="0" err="1">
-                <a:latin typeface="Courier New" panose="02070309020205020404" pitchFamily="49" charset="0"/>
-                <a:cs typeface="Courier New" panose="02070309020205020404" pitchFamily="49" charset="0"/>
+                <a:latin typeface="Menlo" panose="020B0609030804020204" pitchFamily="49" charset="0"/>
+                <a:ea typeface="Menlo" panose="020B0609030804020204" pitchFamily="49" charset="0"/>
+                <a:cs typeface="Menlo" panose="020B0609030804020204" pitchFamily="49" charset="0"/>
               </a:rPr>
               <a:t>runApp</a:t>
             </a:r>
@@ -5594,8 +5685,9 @@
             </a:r>
             <a:r>
               <a:rPr lang="en-GB" b="1" dirty="0">
-                <a:latin typeface="Courier New" panose="02070309020205020404" pitchFamily="49" charset="0"/>
-                <a:cs typeface="Courier New" panose="02070309020205020404" pitchFamily="49" charset="0"/>
+                <a:latin typeface="Menlo" panose="020B0609030804020204" pitchFamily="49" charset="0"/>
+                <a:ea typeface="Menlo" panose="020B0609030804020204" pitchFamily="49" charset="0"/>
+                <a:cs typeface="Menlo" panose="020B0609030804020204" pitchFamily="49" charset="0"/>
               </a:rPr>
               <a:t>Widget</a:t>
             </a:r>
@@ -5653,8 +5745,9 @@
             </a:r>
             <a:r>
               <a:rPr lang="en-GB" b="1" dirty="0">
-                <a:latin typeface="Courier New" panose="02070309020205020404" pitchFamily="49" charset="0"/>
-                <a:cs typeface="Courier New" panose="02070309020205020404" pitchFamily="49" charset="0"/>
+                <a:latin typeface="Menlo" panose="020B0609030804020204" pitchFamily="49" charset="0"/>
+                <a:ea typeface="Menlo" panose="020B0609030804020204" pitchFamily="49" charset="0"/>
+                <a:cs typeface="Menlo" panose="020B0609030804020204" pitchFamily="49" charset="0"/>
               </a:rPr>
               <a:t>Widget</a:t>
             </a:r>
@@ -6083,42 +6176,56 @@
           <a:p>
             <a:r>
               <a:rPr lang="en-GB" sz="1600" dirty="0">
-                <a:latin typeface="Courier" pitchFamily="2" charset="0"/>
+                <a:latin typeface="Menlo" panose="020B0609030804020204" pitchFamily="49" charset="0"/>
+                <a:ea typeface="Menlo" panose="020B0609030804020204" pitchFamily="49" charset="0"/>
+                <a:cs typeface="Menlo" panose="020B0609030804020204" pitchFamily="49" charset="0"/>
               </a:rPr>
               <a:t>import '</a:t>
             </a:r>
             <a:r>
               <a:rPr lang="en-GB" sz="1600" dirty="0" err="1">
-                <a:latin typeface="Courier" pitchFamily="2" charset="0"/>
+                <a:latin typeface="Menlo" panose="020B0609030804020204" pitchFamily="49" charset="0"/>
+                <a:ea typeface="Menlo" panose="020B0609030804020204" pitchFamily="49" charset="0"/>
+                <a:cs typeface="Menlo" panose="020B0609030804020204" pitchFamily="49" charset="0"/>
               </a:rPr>
               <a:t>package:flutter</a:t>
             </a:r>
             <a:r>
               <a:rPr lang="en-GB" sz="1600" dirty="0">
-                <a:latin typeface="Courier" pitchFamily="2" charset="0"/>
+                <a:latin typeface="Menlo" panose="020B0609030804020204" pitchFamily="49" charset="0"/>
+                <a:ea typeface="Menlo" panose="020B0609030804020204" pitchFamily="49" charset="0"/>
+                <a:cs typeface="Menlo" panose="020B0609030804020204" pitchFamily="49" charset="0"/>
               </a:rPr>
               <a:t>/</a:t>
             </a:r>
             <a:r>
               <a:rPr lang="en-GB" sz="1600" dirty="0" err="1">
-                <a:latin typeface="Courier" pitchFamily="2" charset="0"/>
+                <a:latin typeface="Menlo" panose="020B0609030804020204" pitchFamily="49" charset="0"/>
+                <a:ea typeface="Menlo" panose="020B0609030804020204" pitchFamily="49" charset="0"/>
+                <a:cs typeface="Menlo" panose="020B0609030804020204" pitchFamily="49" charset="0"/>
               </a:rPr>
               <a:t>material.dart</a:t>
             </a:r>
             <a:r>
               <a:rPr lang="en-GB" sz="1600" dirty="0">
-                <a:latin typeface="Courier" pitchFamily="2" charset="0"/>
+                <a:latin typeface="Menlo" panose="020B0609030804020204" pitchFamily="49" charset="0"/>
+                <a:ea typeface="Menlo" panose="020B0609030804020204" pitchFamily="49" charset="0"/>
+                <a:cs typeface="Menlo" panose="020B0609030804020204" pitchFamily="49" charset="0"/>
               </a:rPr>
               <a:t>';</a:t>
             </a:r>
             <a:br>
               <a:rPr lang="en-GB" sz="1600" dirty="0">
-                <a:latin typeface="Courier" pitchFamily="2" charset="0"/>
+                <a:latin typeface="Menlo" panose="020B0609030804020204" pitchFamily="49" charset="0"/>
+                <a:ea typeface="Menlo" panose="020B0609030804020204" pitchFamily="49" charset="0"/>
+                <a:cs typeface="Menlo" panose="020B0609030804020204" pitchFamily="49" charset="0"/>
               </a:rPr>
             </a:br>
             <a:r>
               <a:rPr lang="en-GB" sz="1600" dirty="0">
-                <a:latin typeface="Courier" pitchFamily="2" charset="0"/>
+                <a:latin typeface="Menlo" panose="020B0609030804020204" pitchFamily="49" charset="0"/>
+                <a:ea typeface="Menlo" panose="020B0609030804020204" pitchFamily="49" charset="0"/>
+                <a:cs typeface="Menlo" panose="020B0609030804020204" pitchFamily="49" charset="0"/>
               </a:rPr>
               <a:t>void main() {</a:t>
             </a:r>
@@ -6126,31 +6233,41 @@
           <a:p>
             <a:r>
               <a:rPr lang="en-GB" sz="1600" dirty="0">
-                <a:latin typeface="Courier" pitchFamily="2" charset="0"/>
+                <a:latin typeface="Menlo" panose="020B0609030804020204" pitchFamily="49" charset="0"/>
+                <a:ea typeface="Menlo" panose="020B0609030804020204" pitchFamily="49" charset="0"/>
+                <a:cs typeface="Menlo" panose="020B0609030804020204" pitchFamily="49" charset="0"/>
               </a:rPr>
               <a:t>  </a:t>
             </a:r>
             <a:r>
               <a:rPr lang="en-GB" sz="1600" dirty="0" err="1">
-                <a:latin typeface="Courier" pitchFamily="2" charset="0"/>
+                <a:latin typeface="Menlo" panose="020B0609030804020204" pitchFamily="49" charset="0"/>
+                <a:ea typeface="Menlo" panose="020B0609030804020204" pitchFamily="49" charset="0"/>
+                <a:cs typeface="Menlo" panose="020B0609030804020204" pitchFamily="49" charset="0"/>
               </a:rPr>
               <a:t>runApp</a:t>
             </a:r>
             <a:r>
               <a:rPr lang="en-GB" sz="1600" dirty="0">
-                <a:latin typeface="Courier" pitchFamily="2" charset="0"/>
+                <a:latin typeface="Menlo" panose="020B0609030804020204" pitchFamily="49" charset="0"/>
+                <a:ea typeface="Menlo" panose="020B0609030804020204" pitchFamily="49" charset="0"/>
+                <a:cs typeface="Menlo" panose="020B0609030804020204" pitchFamily="49" charset="0"/>
               </a:rPr>
               <a:t>(</a:t>
             </a:r>
             <a:r>
               <a:rPr lang="en-GB" sz="1600" b="1" dirty="0" err="1">
-                <a:latin typeface="Courier" pitchFamily="2" charset="0"/>
+                <a:latin typeface="Menlo" panose="020B0609030804020204" pitchFamily="49" charset="0"/>
+                <a:ea typeface="Menlo" panose="020B0609030804020204" pitchFamily="49" charset="0"/>
+                <a:cs typeface="Menlo" panose="020B0609030804020204" pitchFamily="49" charset="0"/>
               </a:rPr>
               <a:t>MyApp</a:t>
             </a:r>
             <a:r>
               <a:rPr lang="en-GB" sz="1600" dirty="0">
-                <a:latin typeface="Courier" pitchFamily="2" charset="0"/>
+                <a:latin typeface="Menlo" panose="020B0609030804020204" pitchFamily="49" charset="0"/>
+                <a:ea typeface="Menlo" panose="020B0609030804020204" pitchFamily="49" charset="0"/>
+                <a:cs typeface="Menlo" panose="020B0609030804020204" pitchFamily="49" charset="0"/>
               </a:rPr>
               <a:t>());</a:t>
             </a:r>
@@ -6158,42 +6275,56 @@
           <a:p>
             <a:r>
               <a:rPr lang="en-GB" sz="1600" dirty="0">
-                <a:latin typeface="Courier" pitchFamily="2" charset="0"/>
+                <a:latin typeface="Menlo" panose="020B0609030804020204" pitchFamily="49" charset="0"/>
+                <a:ea typeface="Menlo" panose="020B0609030804020204" pitchFamily="49" charset="0"/>
+                <a:cs typeface="Menlo" panose="020B0609030804020204" pitchFamily="49" charset="0"/>
               </a:rPr>
               <a:t>}//main</a:t>
             </a:r>
             <a:br>
               <a:rPr lang="en-GB" sz="1600" dirty="0">
-                <a:latin typeface="Courier" pitchFamily="2" charset="0"/>
+                <a:latin typeface="Menlo" panose="020B0609030804020204" pitchFamily="49" charset="0"/>
+                <a:ea typeface="Menlo" panose="020B0609030804020204" pitchFamily="49" charset="0"/>
+                <a:cs typeface="Menlo" panose="020B0609030804020204" pitchFamily="49" charset="0"/>
               </a:rPr>
             </a:br>
             <a:r>
               <a:rPr lang="en-GB" sz="1600" dirty="0">
-                <a:latin typeface="Courier" pitchFamily="2" charset="0"/>
+                <a:latin typeface="Menlo" panose="020B0609030804020204" pitchFamily="49" charset="0"/>
+                <a:ea typeface="Menlo" panose="020B0609030804020204" pitchFamily="49" charset="0"/>
+                <a:cs typeface="Menlo" panose="020B0609030804020204" pitchFamily="49" charset="0"/>
               </a:rPr>
               <a:t>class </a:t>
             </a:r>
             <a:r>
               <a:rPr lang="en-GB" sz="1600" dirty="0" err="1">
-                <a:latin typeface="Courier" pitchFamily="2" charset="0"/>
+                <a:latin typeface="Menlo" panose="020B0609030804020204" pitchFamily="49" charset="0"/>
+                <a:ea typeface="Menlo" panose="020B0609030804020204" pitchFamily="49" charset="0"/>
+                <a:cs typeface="Menlo" panose="020B0609030804020204" pitchFamily="49" charset="0"/>
               </a:rPr>
               <a:t>MyApp</a:t>
             </a:r>
             <a:r>
               <a:rPr lang="en-GB" sz="1600" dirty="0">
-                <a:latin typeface="Courier" pitchFamily="2" charset="0"/>
+                <a:latin typeface="Menlo" panose="020B0609030804020204" pitchFamily="49" charset="0"/>
+                <a:ea typeface="Menlo" panose="020B0609030804020204" pitchFamily="49" charset="0"/>
+                <a:cs typeface="Menlo" panose="020B0609030804020204" pitchFamily="49" charset="0"/>
               </a:rPr>
               <a:t> extends </a:t>
             </a:r>
             <a:r>
               <a:rPr lang="en-GB" sz="1600" dirty="0" err="1">
-                <a:latin typeface="Courier" pitchFamily="2" charset="0"/>
+                <a:latin typeface="Menlo" panose="020B0609030804020204" pitchFamily="49" charset="0"/>
+                <a:ea typeface="Menlo" panose="020B0609030804020204" pitchFamily="49" charset="0"/>
+                <a:cs typeface="Menlo" panose="020B0609030804020204" pitchFamily="49" charset="0"/>
               </a:rPr>
               <a:t>StatelessWidget</a:t>
             </a:r>
             <a:r>
               <a:rPr lang="en-GB" sz="1600" dirty="0">
-                <a:latin typeface="Courier" pitchFamily="2" charset="0"/>
+                <a:latin typeface="Menlo" panose="020B0609030804020204" pitchFamily="49" charset="0"/>
+                <a:ea typeface="Menlo" panose="020B0609030804020204" pitchFamily="49" charset="0"/>
+                <a:cs typeface="Menlo" panose="020B0609030804020204" pitchFamily="49" charset="0"/>
               </a:rPr>
               <a:t> {</a:t>
             </a:r>
@@ -6201,19 +6332,25 @@
           <a:p>
             <a:r>
               <a:rPr lang="en-GB" sz="1600" dirty="0">
-                <a:latin typeface="Courier" pitchFamily="2" charset="0"/>
+                <a:latin typeface="Menlo" panose="020B0609030804020204" pitchFamily="49" charset="0"/>
+                <a:ea typeface="Menlo" panose="020B0609030804020204" pitchFamily="49" charset="0"/>
+                <a:cs typeface="Menlo" panose="020B0609030804020204" pitchFamily="49" charset="0"/>
               </a:rPr>
               <a:t>  </a:t>
             </a:r>
             <a:r>
               <a:rPr lang="en-GB" sz="1600" dirty="0" err="1">
-                <a:latin typeface="Courier" pitchFamily="2" charset="0"/>
+                <a:latin typeface="Menlo" panose="020B0609030804020204" pitchFamily="49" charset="0"/>
+                <a:ea typeface="Menlo" panose="020B0609030804020204" pitchFamily="49" charset="0"/>
+                <a:cs typeface="Menlo" panose="020B0609030804020204" pitchFamily="49" charset="0"/>
               </a:rPr>
               <a:t>MyApp</a:t>
             </a:r>
             <a:r>
               <a:rPr lang="en-GB" sz="1600" dirty="0">
-                <a:latin typeface="Courier" pitchFamily="2" charset="0"/>
+                <a:latin typeface="Menlo" panose="020B0609030804020204" pitchFamily="49" charset="0"/>
+                <a:ea typeface="Menlo" panose="020B0609030804020204" pitchFamily="49" charset="0"/>
+                <a:cs typeface="Menlo" panose="020B0609030804020204" pitchFamily="49" charset="0"/>
               </a:rPr>
               <a:t>({Key? key}) : super(key: key);</a:t>
             </a:r>
@@ -6221,12 +6358,16 @@
           <a:p>
             <a:br>
               <a:rPr lang="en-GB" sz="1600" dirty="0">
-                <a:latin typeface="Courier" pitchFamily="2" charset="0"/>
+                <a:latin typeface="Menlo" panose="020B0609030804020204" pitchFamily="49" charset="0"/>
+                <a:ea typeface="Menlo" panose="020B0609030804020204" pitchFamily="49" charset="0"/>
+                <a:cs typeface="Menlo" panose="020B0609030804020204" pitchFamily="49" charset="0"/>
               </a:rPr>
             </a:br>
             <a:r>
               <a:rPr lang="en-GB" sz="1600" dirty="0">
-                <a:latin typeface="Courier" pitchFamily="2" charset="0"/>
+                <a:latin typeface="Menlo" panose="020B0609030804020204" pitchFamily="49" charset="0"/>
+                <a:ea typeface="Menlo" panose="020B0609030804020204" pitchFamily="49" charset="0"/>
+                <a:cs typeface="Menlo" panose="020B0609030804020204" pitchFamily="49" charset="0"/>
               </a:rPr>
               <a:t>  @override</a:t>
             </a:r>
@@ -6234,31 +6375,41 @@
           <a:p>
             <a:r>
               <a:rPr lang="en-GB" sz="1600" dirty="0">
-                <a:latin typeface="Courier" pitchFamily="2" charset="0"/>
+                <a:latin typeface="Menlo" panose="020B0609030804020204" pitchFamily="49" charset="0"/>
+                <a:ea typeface="Menlo" panose="020B0609030804020204" pitchFamily="49" charset="0"/>
+                <a:cs typeface="Menlo" panose="020B0609030804020204" pitchFamily="49" charset="0"/>
               </a:rPr>
               <a:t>  Widget </a:t>
             </a:r>
             <a:r>
               <a:rPr lang="en-GB" sz="1600" b="1" dirty="0">
-                <a:latin typeface="Courier" pitchFamily="2" charset="0"/>
+                <a:latin typeface="Menlo" panose="020B0609030804020204" pitchFamily="49" charset="0"/>
+                <a:ea typeface="Menlo" panose="020B0609030804020204" pitchFamily="49" charset="0"/>
+                <a:cs typeface="Menlo" panose="020B0609030804020204" pitchFamily="49" charset="0"/>
               </a:rPr>
               <a:t>build</a:t>
             </a:r>
             <a:r>
               <a:rPr lang="en-GB" sz="1600" dirty="0">
-                <a:latin typeface="Courier" pitchFamily="2" charset="0"/>
+                <a:latin typeface="Menlo" panose="020B0609030804020204" pitchFamily="49" charset="0"/>
+                <a:ea typeface="Menlo" panose="020B0609030804020204" pitchFamily="49" charset="0"/>
+                <a:cs typeface="Menlo" panose="020B0609030804020204" pitchFamily="49" charset="0"/>
               </a:rPr>
               <a:t>(</a:t>
             </a:r>
             <a:r>
               <a:rPr lang="en-GB" sz="1600" dirty="0" err="1">
-                <a:latin typeface="Courier" pitchFamily="2" charset="0"/>
+                <a:latin typeface="Menlo" panose="020B0609030804020204" pitchFamily="49" charset="0"/>
+                <a:ea typeface="Menlo" panose="020B0609030804020204" pitchFamily="49" charset="0"/>
+                <a:cs typeface="Menlo" panose="020B0609030804020204" pitchFamily="49" charset="0"/>
               </a:rPr>
               <a:t>BuildContext</a:t>
             </a:r>
             <a:r>
               <a:rPr lang="en-GB" sz="1600" dirty="0">
-                <a:latin typeface="Courier" pitchFamily="2" charset="0"/>
+                <a:latin typeface="Menlo" panose="020B0609030804020204" pitchFamily="49" charset="0"/>
+                <a:ea typeface="Menlo" panose="020B0609030804020204" pitchFamily="49" charset="0"/>
+                <a:cs typeface="Menlo" panose="020B0609030804020204" pitchFamily="49" charset="0"/>
               </a:rPr>
               <a:t> context) {</a:t>
             </a:r>
@@ -6266,19 +6417,25 @@
           <a:p>
             <a:r>
               <a:rPr lang="en-GB" sz="1600" dirty="0">
-                <a:latin typeface="Courier" pitchFamily="2" charset="0"/>
+                <a:latin typeface="Menlo" panose="020B0609030804020204" pitchFamily="49" charset="0"/>
+                <a:ea typeface="Menlo" panose="020B0609030804020204" pitchFamily="49" charset="0"/>
+                <a:cs typeface="Menlo" panose="020B0609030804020204" pitchFamily="49" charset="0"/>
               </a:rPr>
               <a:t>    return </a:t>
             </a:r>
             <a:r>
               <a:rPr lang="en-GB" sz="1600" b="1" dirty="0" err="1">
-                <a:latin typeface="Courier" pitchFamily="2" charset="0"/>
+                <a:latin typeface="Menlo" panose="020B0609030804020204" pitchFamily="49" charset="0"/>
+                <a:ea typeface="Menlo" panose="020B0609030804020204" pitchFamily="49" charset="0"/>
+                <a:cs typeface="Menlo" panose="020B0609030804020204" pitchFamily="49" charset="0"/>
               </a:rPr>
               <a:t>MaterialApp</a:t>
             </a:r>
             <a:r>
               <a:rPr lang="en-GB" sz="1600" dirty="0">
-                <a:latin typeface="Courier" pitchFamily="2" charset="0"/>
+                <a:latin typeface="Menlo" panose="020B0609030804020204" pitchFamily="49" charset="0"/>
+                <a:ea typeface="Menlo" panose="020B0609030804020204" pitchFamily="49" charset="0"/>
+                <a:cs typeface="Menlo" panose="020B0609030804020204" pitchFamily="49" charset="0"/>
               </a:rPr>
               <a:t>(</a:t>
             </a:r>
@@ -6286,7 +6443,9 @@
           <a:p>
             <a:r>
               <a:rPr lang="en-GB" sz="1600" dirty="0">
-                <a:latin typeface="Courier" pitchFamily="2" charset="0"/>
+                <a:latin typeface="Menlo" panose="020B0609030804020204" pitchFamily="49" charset="0"/>
+                <a:ea typeface="Menlo" panose="020B0609030804020204" pitchFamily="49" charset="0"/>
+                <a:cs typeface="Menlo" panose="020B0609030804020204" pitchFamily="49" charset="0"/>
               </a:rPr>
               <a:t>      title: 'Welcome to Flutter’,</a:t>
             </a:r>
@@ -6294,19 +6453,25 @@
           <a:p>
             <a:r>
               <a:rPr lang="en-GB" sz="1600" dirty="0">
-                <a:latin typeface="Courier" pitchFamily="2" charset="0"/>
+                <a:latin typeface="Menlo" panose="020B0609030804020204" pitchFamily="49" charset="0"/>
+                <a:ea typeface="Menlo" panose="020B0609030804020204" pitchFamily="49" charset="0"/>
+                <a:cs typeface="Menlo" panose="020B0609030804020204" pitchFamily="49" charset="0"/>
               </a:rPr>
               <a:t>      home: </a:t>
             </a:r>
             <a:r>
               <a:rPr lang="en-GB" sz="1600" b="1" dirty="0">
-                <a:latin typeface="Courier" pitchFamily="2" charset="0"/>
+                <a:latin typeface="Menlo" panose="020B0609030804020204" pitchFamily="49" charset="0"/>
+                <a:ea typeface="Menlo" panose="020B0609030804020204" pitchFamily="49" charset="0"/>
+                <a:cs typeface="Menlo" panose="020B0609030804020204" pitchFamily="49" charset="0"/>
               </a:rPr>
               <a:t>Scaffold</a:t>
             </a:r>
             <a:r>
               <a:rPr lang="en-GB" sz="1600" dirty="0">
-                <a:latin typeface="Courier" pitchFamily="2" charset="0"/>
+                <a:latin typeface="Menlo" panose="020B0609030804020204" pitchFamily="49" charset="0"/>
+                <a:ea typeface="Menlo" panose="020B0609030804020204" pitchFamily="49" charset="0"/>
+                <a:cs typeface="Menlo" panose="020B0609030804020204" pitchFamily="49" charset="0"/>
               </a:rPr>
               <a:t>(</a:t>
             </a:r>
@@ -6314,43 +6479,57 @@
           <a:p>
             <a:r>
               <a:rPr lang="en-GB" sz="1600" dirty="0">
-                <a:latin typeface="Courier" pitchFamily="2" charset="0"/>
+                <a:latin typeface="Menlo" panose="020B0609030804020204" pitchFamily="49" charset="0"/>
+                <a:ea typeface="Menlo" panose="020B0609030804020204" pitchFamily="49" charset="0"/>
+                <a:cs typeface="Menlo" panose="020B0609030804020204" pitchFamily="49" charset="0"/>
               </a:rPr>
               <a:t>      </a:t>
             </a:r>
             <a:r>
               <a:rPr lang="en-GB" sz="1600" dirty="0" err="1">
-                <a:latin typeface="Courier" pitchFamily="2" charset="0"/>
+                <a:latin typeface="Menlo" panose="020B0609030804020204" pitchFamily="49" charset="0"/>
+                <a:ea typeface="Menlo" panose="020B0609030804020204" pitchFamily="49" charset="0"/>
+                <a:cs typeface="Menlo" panose="020B0609030804020204" pitchFamily="49" charset="0"/>
               </a:rPr>
               <a:t>appBar</a:t>
             </a:r>
             <a:r>
               <a:rPr lang="en-GB" sz="1600" dirty="0">
-                <a:latin typeface="Courier" pitchFamily="2" charset="0"/>
+                <a:latin typeface="Menlo" panose="020B0609030804020204" pitchFamily="49" charset="0"/>
+                <a:ea typeface="Menlo" panose="020B0609030804020204" pitchFamily="49" charset="0"/>
+                <a:cs typeface="Menlo" panose="020B0609030804020204" pitchFamily="49" charset="0"/>
               </a:rPr>
               <a:t>: </a:t>
             </a:r>
             <a:r>
               <a:rPr lang="en-GB" sz="1600" b="1" dirty="0" err="1">
-                <a:latin typeface="Courier" pitchFamily="2" charset="0"/>
+                <a:latin typeface="Menlo" panose="020B0609030804020204" pitchFamily="49" charset="0"/>
+                <a:ea typeface="Menlo" panose="020B0609030804020204" pitchFamily="49" charset="0"/>
+                <a:cs typeface="Menlo" panose="020B0609030804020204" pitchFamily="49" charset="0"/>
               </a:rPr>
               <a:t>AppBar</a:t>
             </a:r>
             <a:r>
               <a:rPr lang="en-GB" sz="1600" dirty="0">
-                <a:latin typeface="Courier" pitchFamily="2" charset="0"/>
+                <a:latin typeface="Menlo" panose="020B0609030804020204" pitchFamily="49" charset="0"/>
+                <a:ea typeface="Menlo" panose="020B0609030804020204" pitchFamily="49" charset="0"/>
+                <a:cs typeface="Menlo" panose="020B0609030804020204" pitchFamily="49" charset="0"/>
               </a:rPr>
               <a:t>(title: </a:t>
             </a:r>
             <a:r>
               <a:rPr lang="en-GB" sz="1600" b="1" dirty="0">
-                <a:latin typeface="Courier" pitchFamily="2" charset="0"/>
+                <a:latin typeface="Menlo" panose="020B0609030804020204" pitchFamily="49" charset="0"/>
+                <a:ea typeface="Menlo" panose="020B0609030804020204" pitchFamily="49" charset="0"/>
+                <a:cs typeface="Menlo" panose="020B0609030804020204" pitchFamily="49" charset="0"/>
               </a:rPr>
               <a:t>Text</a:t>
             </a:r>
             <a:r>
               <a:rPr lang="en-GB" sz="1600" dirty="0">
-                <a:latin typeface="Courier" pitchFamily="2" charset="0"/>
+                <a:latin typeface="Menlo" panose="020B0609030804020204" pitchFamily="49" charset="0"/>
+                <a:ea typeface="Menlo" panose="020B0609030804020204" pitchFamily="49" charset="0"/>
+                <a:cs typeface="Menlo" panose="020B0609030804020204" pitchFamily="49" charset="0"/>
               </a:rPr>
               <a:t>('Welcome to Flutter'),),</a:t>
             </a:r>
@@ -6358,31 +6537,41 @@
           <a:p>
             <a:r>
               <a:rPr lang="en-GB" sz="1600" dirty="0">
-                <a:latin typeface="Courier" pitchFamily="2" charset="0"/>
+                <a:latin typeface="Menlo" panose="020B0609030804020204" pitchFamily="49" charset="0"/>
+                <a:ea typeface="Menlo" panose="020B0609030804020204" pitchFamily="49" charset="0"/>
+                <a:cs typeface="Menlo" panose="020B0609030804020204" pitchFamily="49" charset="0"/>
               </a:rPr>
               <a:t>      body: </a:t>
             </a:r>
             <a:r>
               <a:rPr lang="en-GB" sz="1600" b="1" dirty="0" err="1">
-                <a:latin typeface="Courier" pitchFamily="2" charset="0"/>
+                <a:latin typeface="Menlo" panose="020B0609030804020204" pitchFamily="49" charset="0"/>
+                <a:ea typeface="Menlo" panose="020B0609030804020204" pitchFamily="49" charset="0"/>
+                <a:cs typeface="Menlo" panose="020B0609030804020204" pitchFamily="49" charset="0"/>
               </a:rPr>
               <a:t>Center</a:t>
             </a:r>
             <a:r>
               <a:rPr lang="en-GB" sz="1600" dirty="0">
-                <a:latin typeface="Courier" pitchFamily="2" charset="0"/>
+                <a:latin typeface="Menlo" panose="020B0609030804020204" pitchFamily="49" charset="0"/>
+                <a:ea typeface="Menlo" panose="020B0609030804020204" pitchFamily="49" charset="0"/>
+                <a:cs typeface="Menlo" panose="020B0609030804020204" pitchFamily="49" charset="0"/>
               </a:rPr>
               <a:t>(child: </a:t>
             </a:r>
             <a:r>
               <a:rPr lang="en-GB" sz="1600" b="1" dirty="0">
-                <a:latin typeface="Courier" pitchFamily="2" charset="0"/>
+                <a:latin typeface="Menlo" panose="020B0609030804020204" pitchFamily="49" charset="0"/>
+                <a:ea typeface="Menlo" panose="020B0609030804020204" pitchFamily="49" charset="0"/>
+                <a:cs typeface="Menlo" panose="020B0609030804020204" pitchFamily="49" charset="0"/>
               </a:rPr>
               <a:t>Text</a:t>
             </a:r>
             <a:r>
               <a:rPr lang="en-GB" sz="1600" dirty="0">
-                <a:latin typeface="Courier" pitchFamily="2" charset="0"/>
+                <a:latin typeface="Menlo" panose="020B0609030804020204" pitchFamily="49" charset="0"/>
+                <a:ea typeface="Menlo" panose="020B0609030804020204" pitchFamily="49" charset="0"/>
+                <a:cs typeface="Menlo" panose="020B0609030804020204" pitchFamily="49" charset="0"/>
               </a:rPr>
               <a:t>('Hello World'),),),</a:t>
             </a:r>
@@ -6390,7 +6579,9 @@
           <a:p>
             <a:r>
               <a:rPr lang="en-GB" sz="1600" dirty="0">
-                <a:latin typeface="Courier" pitchFamily="2" charset="0"/>
+                <a:latin typeface="Menlo" panose="020B0609030804020204" pitchFamily="49" charset="0"/>
+                <a:ea typeface="Menlo" panose="020B0609030804020204" pitchFamily="49" charset="0"/>
+                <a:cs typeface="Menlo" panose="020B0609030804020204" pitchFamily="49" charset="0"/>
               </a:rPr>
               <a:t>    );</a:t>
             </a:r>
@@ -6398,7 +6589,9 @@
           <a:p>
             <a:r>
               <a:rPr lang="en-GB" sz="1600" dirty="0">
-                <a:latin typeface="Courier" pitchFamily="2" charset="0"/>
+                <a:latin typeface="Menlo" panose="020B0609030804020204" pitchFamily="49" charset="0"/>
+                <a:ea typeface="Menlo" panose="020B0609030804020204" pitchFamily="49" charset="0"/>
+                <a:cs typeface="Menlo" panose="020B0609030804020204" pitchFamily="49" charset="0"/>
               </a:rPr>
               <a:t>  }//build</a:t>
             </a:r>
@@ -6406,18 +6599,24 @@
           <a:p>
             <a:r>
               <a:rPr lang="en-GB" sz="1600" dirty="0">
-                <a:latin typeface="Courier" pitchFamily="2" charset="0"/>
+                <a:latin typeface="Menlo" panose="020B0609030804020204" pitchFamily="49" charset="0"/>
+                <a:ea typeface="Menlo" panose="020B0609030804020204" pitchFamily="49" charset="0"/>
+                <a:cs typeface="Menlo" panose="020B0609030804020204" pitchFamily="49" charset="0"/>
               </a:rPr>
               <a:t>}//</a:t>
             </a:r>
             <a:r>
               <a:rPr lang="en-GB" sz="1600" dirty="0" err="1">
-                <a:latin typeface="Courier" pitchFamily="2" charset="0"/>
+                <a:latin typeface="Menlo" panose="020B0609030804020204" pitchFamily="49" charset="0"/>
+                <a:ea typeface="Menlo" panose="020B0609030804020204" pitchFamily="49" charset="0"/>
+                <a:cs typeface="Menlo" panose="020B0609030804020204" pitchFamily="49" charset="0"/>
               </a:rPr>
               <a:t>MyApp</a:t>
             </a:r>
             <a:endParaRPr lang="en-GB" sz="1600" dirty="0">
-              <a:latin typeface="Courier" pitchFamily="2" charset="0"/>
+              <a:latin typeface="Menlo" panose="020B0609030804020204" pitchFamily="49" charset="0"/>
+              <a:ea typeface="Menlo" panose="020B0609030804020204" pitchFamily="49" charset="0"/>
+              <a:cs typeface="Menlo" panose="020B0609030804020204" pitchFamily="49" charset="0"/>
             </a:endParaRPr>
           </a:p>
         </p:txBody>
@@ -6464,8 +6663,9 @@
             </a:r>
             <a:r>
               <a:rPr lang="en-GB" b="1" dirty="0">
-                <a:latin typeface="Courier New" panose="02070309020205020404" pitchFamily="49" charset="0"/>
-                <a:cs typeface="Courier New" panose="02070309020205020404" pitchFamily="49" charset="0"/>
+                <a:latin typeface="Menlo" panose="020B0609030804020204" pitchFamily="49" charset="0"/>
+                <a:ea typeface="Menlo" panose="020B0609030804020204" pitchFamily="49" charset="0"/>
+                <a:cs typeface="Menlo" panose="020B0609030804020204" pitchFamily="49" charset="0"/>
               </a:rPr>
               <a:t>Widgets</a:t>
             </a:r>
@@ -6516,8 +6716,9 @@
             </a:r>
             <a:r>
               <a:rPr lang="en-GB" dirty="0">
-                <a:latin typeface="Courier New" panose="02070309020205020404" pitchFamily="49" charset="0"/>
-                <a:cs typeface="Courier New" panose="02070309020205020404" pitchFamily="49" charset="0"/>
+                <a:latin typeface="Menlo" panose="020B0609030804020204" pitchFamily="49" charset="0"/>
+                <a:ea typeface="Menlo" panose="020B0609030804020204" pitchFamily="49" charset="0"/>
+                <a:cs typeface="Menlo" panose="020B0609030804020204" pitchFamily="49" charset="0"/>
               </a:rPr>
               <a:t>Widget</a:t>
             </a:r>
@@ -6549,8 +6750,8 @@
         </p:nvCxnSpPr>
         <p:spPr>
           <a:xfrm flipV="1">
-            <a:off x="1889090" y="2391508"/>
-            <a:ext cx="6812783" cy="1711998"/>
+            <a:off x="1944547" y="2391508"/>
+            <a:ext cx="6757326" cy="1613333"/>
           </a:xfrm>
           <a:prstGeom prst="straightConnector1">
             <a:avLst/>
@@ -6753,7 +6954,9 @@
             <a:pPr algn="ctr"/>
             <a:r>
               <a:rPr lang="en-IT" dirty="0">
-                <a:latin typeface="Courier" pitchFamily="2" charset="0"/>
+                <a:latin typeface="Menlo" panose="020B0609030804020204" pitchFamily="49" charset="0"/>
+                <a:ea typeface="Menlo" panose="020B0609030804020204" pitchFamily="49" charset="0"/>
+                <a:cs typeface="Menlo" panose="020B0609030804020204" pitchFamily="49" charset="0"/>
               </a:rPr>
               <a:t>main</a:t>
             </a:r>
@@ -6803,7 +7006,9 @@
             <a:pPr algn="ctr"/>
             <a:r>
               <a:rPr lang="en-IT" dirty="0">
-                <a:latin typeface="Courier" pitchFamily="2" charset="0"/>
+                <a:latin typeface="Menlo" panose="020B0609030804020204" pitchFamily="49" charset="0"/>
+                <a:ea typeface="Menlo" panose="020B0609030804020204" pitchFamily="49" charset="0"/>
+                <a:cs typeface="Menlo" panose="020B0609030804020204" pitchFamily="49" charset="0"/>
               </a:rPr>
               <a:t>Text</a:t>
             </a:r>
@@ -6853,7 +7058,9 @@
             <a:pPr algn="ctr"/>
             <a:r>
               <a:rPr lang="en-IT" dirty="0">
-                <a:latin typeface="Courier" pitchFamily="2" charset="0"/>
+                <a:latin typeface="Menlo" panose="020B0609030804020204" pitchFamily="49" charset="0"/>
+                <a:ea typeface="Menlo" panose="020B0609030804020204" pitchFamily="49" charset="0"/>
+                <a:cs typeface="Menlo" panose="020B0609030804020204" pitchFamily="49" charset="0"/>
               </a:rPr>
               <a:t>MyApp</a:t>
             </a:r>
@@ -6903,7 +7110,9 @@
             <a:pPr algn="ctr"/>
             <a:r>
               <a:rPr lang="en-IT" dirty="0">
-                <a:latin typeface="Courier" pitchFamily="2" charset="0"/>
+                <a:latin typeface="Menlo" panose="020B0609030804020204" pitchFamily="49" charset="0"/>
+                <a:ea typeface="Menlo" panose="020B0609030804020204" pitchFamily="49" charset="0"/>
+                <a:cs typeface="Menlo" panose="020B0609030804020204" pitchFamily="49" charset="0"/>
               </a:rPr>
               <a:t>Scaffold</a:t>
             </a:r>
@@ -6953,7 +7162,9 @@
             <a:pPr algn="ctr"/>
             <a:r>
               <a:rPr lang="en-IT" dirty="0">
-                <a:latin typeface="Courier" pitchFamily="2" charset="0"/>
+                <a:latin typeface="Menlo" panose="020B0609030804020204" pitchFamily="49" charset="0"/>
+                <a:ea typeface="Menlo" panose="020B0609030804020204" pitchFamily="49" charset="0"/>
+                <a:cs typeface="Menlo" panose="020B0609030804020204" pitchFamily="49" charset="0"/>
               </a:rPr>
               <a:t>AppBar</a:t>
             </a:r>
@@ -7003,7 +7214,9 @@
             <a:pPr algn="ctr"/>
             <a:r>
               <a:rPr lang="en-IT" dirty="0">
-                <a:latin typeface="Courier" pitchFamily="2" charset="0"/>
+                <a:latin typeface="Menlo" panose="020B0609030804020204" pitchFamily="49" charset="0"/>
+                <a:ea typeface="Menlo" panose="020B0609030804020204" pitchFamily="49" charset="0"/>
+                <a:cs typeface="Menlo" panose="020B0609030804020204" pitchFamily="49" charset="0"/>
               </a:rPr>
               <a:t>Center</a:t>
             </a:r>
@@ -7053,7 +7266,9 @@
             <a:pPr algn="ctr"/>
             <a:r>
               <a:rPr lang="en-IT" sz="1400" dirty="0">
-                <a:latin typeface="Courier" pitchFamily="2" charset="0"/>
+                <a:latin typeface="Menlo" panose="020B0609030804020204" pitchFamily="49" charset="0"/>
+                <a:ea typeface="Menlo" panose="020B0609030804020204" pitchFamily="49" charset="0"/>
+                <a:cs typeface="Menlo" panose="020B0609030804020204" pitchFamily="49" charset="0"/>
               </a:rPr>
               <a:t>MaterialApp</a:t>
             </a:r>
@@ -7103,7 +7318,9 @@
             <a:pPr algn="ctr"/>
             <a:r>
               <a:rPr lang="en-IT" dirty="0">
-                <a:latin typeface="Courier" pitchFamily="2" charset="0"/>
+                <a:latin typeface="Menlo" panose="020B0609030804020204" pitchFamily="49" charset="0"/>
+                <a:ea typeface="Menlo" panose="020B0609030804020204" pitchFamily="49" charset="0"/>
+                <a:cs typeface="Menlo" panose="020B0609030804020204" pitchFamily="49" charset="0"/>
               </a:rPr>
               <a:t>Text</a:t>
             </a:r>
@@ -7139,42 +7356,56 @@
           <a:p>
             <a:r>
               <a:rPr lang="en-GB" sz="1600" dirty="0">
-                <a:latin typeface="Courier" pitchFamily="2" charset="0"/>
+                <a:latin typeface="Menlo" panose="020B0609030804020204" pitchFamily="49" charset="0"/>
+                <a:ea typeface="Menlo" panose="020B0609030804020204" pitchFamily="49" charset="0"/>
+                <a:cs typeface="Menlo" panose="020B0609030804020204" pitchFamily="49" charset="0"/>
               </a:rPr>
               <a:t>import '</a:t>
             </a:r>
             <a:r>
               <a:rPr lang="en-GB" sz="1600" dirty="0" err="1">
-                <a:latin typeface="Courier" pitchFamily="2" charset="0"/>
+                <a:latin typeface="Menlo" panose="020B0609030804020204" pitchFamily="49" charset="0"/>
+                <a:ea typeface="Menlo" panose="020B0609030804020204" pitchFamily="49" charset="0"/>
+                <a:cs typeface="Menlo" panose="020B0609030804020204" pitchFamily="49" charset="0"/>
               </a:rPr>
               <a:t>package:flutter</a:t>
             </a:r>
             <a:r>
               <a:rPr lang="en-GB" sz="1600" dirty="0">
-                <a:latin typeface="Courier" pitchFamily="2" charset="0"/>
+                <a:latin typeface="Menlo" panose="020B0609030804020204" pitchFamily="49" charset="0"/>
+                <a:ea typeface="Menlo" panose="020B0609030804020204" pitchFamily="49" charset="0"/>
+                <a:cs typeface="Menlo" panose="020B0609030804020204" pitchFamily="49" charset="0"/>
               </a:rPr>
               <a:t>/</a:t>
             </a:r>
             <a:r>
               <a:rPr lang="en-GB" sz="1600" dirty="0" err="1">
-                <a:latin typeface="Courier" pitchFamily="2" charset="0"/>
+                <a:latin typeface="Menlo" panose="020B0609030804020204" pitchFamily="49" charset="0"/>
+                <a:ea typeface="Menlo" panose="020B0609030804020204" pitchFamily="49" charset="0"/>
+                <a:cs typeface="Menlo" panose="020B0609030804020204" pitchFamily="49" charset="0"/>
               </a:rPr>
               <a:t>material.dart</a:t>
             </a:r>
             <a:r>
               <a:rPr lang="en-GB" sz="1600" dirty="0">
-                <a:latin typeface="Courier" pitchFamily="2" charset="0"/>
+                <a:latin typeface="Menlo" panose="020B0609030804020204" pitchFamily="49" charset="0"/>
+                <a:ea typeface="Menlo" panose="020B0609030804020204" pitchFamily="49" charset="0"/>
+                <a:cs typeface="Menlo" panose="020B0609030804020204" pitchFamily="49" charset="0"/>
               </a:rPr>
               <a:t>';</a:t>
             </a:r>
             <a:br>
               <a:rPr lang="en-GB" sz="1600" dirty="0">
-                <a:latin typeface="Courier" pitchFamily="2" charset="0"/>
+                <a:latin typeface="Menlo" panose="020B0609030804020204" pitchFamily="49" charset="0"/>
+                <a:ea typeface="Menlo" panose="020B0609030804020204" pitchFamily="49" charset="0"/>
+                <a:cs typeface="Menlo" panose="020B0609030804020204" pitchFamily="49" charset="0"/>
               </a:rPr>
             </a:br>
             <a:r>
               <a:rPr lang="en-GB" sz="1600" dirty="0">
-                <a:latin typeface="Courier" pitchFamily="2" charset="0"/>
+                <a:latin typeface="Menlo" panose="020B0609030804020204" pitchFamily="49" charset="0"/>
+                <a:ea typeface="Menlo" panose="020B0609030804020204" pitchFamily="49" charset="0"/>
+                <a:cs typeface="Menlo" panose="020B0609030804020204" pitchFamily="49" charset="0"/>
               </a:rPr>
               <a:t>void main() {</a:t>
             </a:r>
@@ -7182,31 +7413,41 @@
           <a:p>
             <a:r>
               <a:rPr lang="en-GB" sz="1600" dirty="0">
-                <a:latin typeface="Courier" pitchFamily="2" charset="0"/>
+                <a:latin typeface="Menlo" panose="020B0609030804020204" pitchFamily="49" charset="0"/>
+                <a:ea typeface="Menlo" panose="020B0609030804020204" pitchFamily="49" charset="0"/>
+                <a:cs typeface="Menlo" panose="020B0609030804020204" pitchFamily="49" charset="0"/>
               </a:rPr>
               <a:t>  </a:t>
             </a:r>
             <a:r>
               <a:rPr lang="en-GB" sz="1600" dirty="0" err="1">
-                <a:latin typeface="Courier" pitchFamily="2" charset="0"/>
+                <a:latin typeface="Menlo" panose="020B0609030804020204" pitchFamily="49" charset="0"/>
+                <a:ea typeface="Menlo" panose="020B0609030804020204" pitchFamily="49" charset="0"/>
+                <a:cs typeface="Menlo" panose="020B0609030804020204" pitchFamily="49" charset="0"/>
               </a:rPr>
               <a:t>runApp</a:t>
             </a:r>
             <a:r>
               <a:rPr lang="en-GB" sz="1600" dirty="0">
-                <a:latin typeface="Courier" pitchFamily="2" charset="0"/>
+                <a:latin typeface="Menlo" panose="020B0609030804020204" pitchFamily="49" charset="0"/>
+                <a:ea typeface="Menlo" panose="020B0609030804020204" pitchFamily="49" charset="0"/>
+                <a:cs typeface="Menlo" panose="020B0609030804020204" pitchFamily="49" charset="0"/>
               </a:rPr>
               <a:t>(</a:t>
             </a:r>
             <a:r>
               <a:rPr lang="en-GB" sz="1600" b="1" dirty="0" err="1">
-                <a:latin typeface="Courier" pitchFamily="2" charset="0"/>
+                <a:latin typeface="Menlo" panose="020B0609030804020204" pitchFamily="49" charset="0"/>
+                <a:ea typeface="Menlo" panose="020B0609030804020204" pitchFamily="49" charset="0"/>
+                <a:cs typeface="Menlo" panose="020B0609030804020204" pitchFamily="49" charset="0"/>
               </a:rPr>
               <a:t>MyApp</a:t>
             </a:r>
             <a:r>
               <a:rPr lang="en-GB" sz="1600" dirty="0">
-                <a:latin typeface="Courier" pitchFamily="2" charset="0"/>
+                <a:latin typeface="Menlo" panose="020B0609030804020204" pitchFamily="49" charset="0"/>
+                <a:ea typeface="Menlo" panose="020B0609030804020204" pitchFamily="49" charset="0"/>
+                <a:cs typeface="Menlo" panose="020B0609030804020204" pitchFamily="49" charset="0"/>
               </a:rPr>
               <a:t>());</a:t>
             </a:r>
@@ -7214,42 +7455,56 @@
           <a:p>
             <a:r>
               <a:rPr lang="en-GB" sz="1600" dirty="0">
-                <a:latin typeface="Courier" pitchFamily="2" charset="0"/>
+                <a:latin typeface="Menlo" panose="020B0609030804020204" pitchFamily="49" charset="0"/>
+                <a:ea typeface="Menlo" panose="020B0609030804020204" pitchFamily="49" charset="0"/>
+                <a:cs typeface="Menlo" panose="020B0609030804020204" pitchFamily="49" charset="0"/>
               </a:rPr>
               <a:t>}//main</a:t>
             </a:r>
             <a:br>
               <a:rPr lang="en-GB" sz="1600" dirty="0">
-                <a:latin typeface="Courier" pitchFamily="2" charset="0"/>
+                <a:latin typeface="Menlo" panose="020B0609030804020204" pitchFamily="49" charset="0"/>
+                <a:ea typeface="Menlo" panose="020B0609030804020204" pitchFamily="49" charset="0"/>
+                <a:cs typeface="Menlo" panose="020B0609030804020204" pitchFamily="49" charset="0"/>
               </a:rPr>
             </a:br>
             <a:r>
               <a:rPr lang="en-GB" sz="1600" dirty="0">
-                <a:latin typeface="Courier" pitchFamily="2" charset="0"/>
+                <a:latin typeface="Menlo" panose="020B0609030804020204" pitchFamily="49" charset="0"/>
+                <a:ea typeface="Menlo" panose="020B0609030804020204" pitchFamily="49" charset="0"/>
+                <a:cs typeface="Menlo" panose="020B0609030804020204" pitchFamily="49" charset="0"/>
               </a:rPr>
               <a:t>class </a:t>
             </a:r>
             <a:r>
               <a:rPr lang="en-GB" sz="1600" dirty="0" err="1">
-                <a:latin typeface="Courier" pitchFamily="2" charset="0"/>
+                <a:latin typeface="Menlo" panose="020B0609030804020204" pitchFamily="49" charset="0"/>
+                <a:ea typeface="Menlo" panose="020B0609030804020204" pitchFamily="49" charset="0"/>
+                <a:cs typeface="Menlo" panose="020B0609030804020204" pitchFamily="49" charset="0"/>
               </a:rPr>
               <a:t>MyApp</a:t>
             </a:r>
             <a:r>
               <a:rPr lang="en-GB" sz="1600" dirty="0">
-                <a:latin typeface="Courier" pitchFamily="2" charset="0"/>
+                <a:latin typeface="Menlo" panose="020B0609030804020204" pitchFamily="49" charset="0"/>
+                <a:ea typeface="Menlo" panose="020B0609030804020204" pitchFamily="49" charset="0"/>
+                <a:cs typeface="Menlo" panose="020B0609030804020204" pitchFamily="49" charset="0"/>
               </a:rPr>
               <a:t> extends </a:t>
             </a:r>
             <a:r>
               <a:rPr lang="en-GB" sz="1600" dirty="0" err="1">
-                <a:latin typeface="Courier" pitchFamily="2" charset="0"/>
+                <a:latin typeface="Menlo" panose="020B0609030804020204" pitchFamily="49" charset="0"/>
+                <a:ea typeface="Menlo" panose="020B0609030804020204" pitchFamily="49" charset="0"/>
+                <a:cs typeface="Menlo" panose="020B0609030804020204" pitchFamily="49" charset="0"/>
               </a:rPr>
               <a:t>StatelessWidget</a:t>
             </a:r>
             <a:r>
               <a:rPr lang="en-GB" sz="1600" dirty="0">
-                <a:latin typeface="Courier" pitchFamily="2" charset="0"/>
+                <a:latin typeface="Menlo" panose="020B0609030804020204" pitchFamily="49" charset="0"/>
+                <a:ea typeface="Menlo" panose="020B0609030804020204" pitchFamily="49" charset="0"/>
+                <a:cs typeface="Menlo" panose="020B0609030804020204" pitchFamily="49" charset="0"/>
               </a:rPr>
               <a:t> {</a:t>
             </a:r>
@@ -7257,19 +7512,25 @@
           <a:p>
             <a:r>
               <a:rPr lang="en-GB" sz="1600" dirty="0">
-                <a:latin typeface="Courier" pitchFamily="2" charset="0"/>
+                <a:latin typeface="Menlo" panose="020B0609030804020204" pitchFamily="49" charset="0"/>
+                <a:ea typeface="Menlo" panose="020B0609030804020204" pitchFamily="49" charset="0"/>
+                <a:cs typeface="Menlo" panose="020B0609030804020204" pitchFamily="49" charset="0"/>
               </a:rPr>
               <a:t>  </a:t>
             </a:r>
             <a:r>
               <a:rPr lang="en-GB" sz="1600" dirty="0" err="1">
-                <a:latin typeface="Courier" pitchFamily="2" charset="0"/>
+                <a:latin typeface="Menlo" panose="020B0609030804020204" pitchFamily="49" charset="0"/>
+                <a:ea typeface="Menlo" panose="020B0609030804020204" pitchFamily="49" charset="0"/>
+                <a:cs typeface="Menlo" panose="020B0609030804020204" pitchFamily="49" charset="0"/>
               </a:rPr>
               <a:t>MyApp</a:t>
             </a:r>
             <a:r>
               <a:rPr lang="en-GB" sz="1600" dirty="0">
-                <a:latin typeface="Courier" pitchFamily="2" charset="0"/>
+                <a:latin typeface="Menlo" panose="020B0609030804020204" pitchFamily="49" charset="0"/>
+                <a:ea typeface="Menlo" panose="020B0609030804020204" pitchFamily="49" charset="0"/>
+                <a:cs typeface="Menlo" panose="020B0609030804020204" pitchFamily="49" charset="0"/>
               </a:rPr>
               <a:t>({Key? key}) : super(key: key);</a:t>
             </a:r>
@@ -7277,12 +7538,16 @@
           <a:p>
             <a:br>
               <a:rPr lang="en-GB" sz="1600" dirty="0">
-                <a:latin typeface="Courier" pitchFamily="2" charset="0"/>
+                <a:latin typeface="Menlo" panose="020B0609030804020204" pitchFamily="49" charset="0"/>
+                <a:ea typeface="Menlo" panose="020B0609030804020204" pitchFamily="49" charset="0"/>
+                <a:cs typeface="Menlo" panose="020B0609030804020204" pitchFamily="49" charset="0"/>
               </a:rPr>
             </a:br>
             <a:r>
               <a:rPr lang="en-GB" sz="1600" dirty="0">
-                <a:latin typeface="Courier" pitchFamily="2" charset="0"/>
+                <a:latin typeface="Menlo" panose="020B0609030804020204" pitchFamily="49" charset="0"/>
+                <a:ea typeface="Menlo" panose="020B0609030804020204" pitchFamily="49" charset="0"/>
+                <a:cs typeface="Menlo" panose="020B0609030804020204" pitchFamily="49" charset="0"/>
               </a:rPr>
               <a:t>  @override</a:t>
             </a:r>
@@ -7290,31 +7555,41 @@
           <a:p>
             <a:r>
               <a:rPr lang="en-GB" sz="1600" dirty="0">
-                <a:latin typeface="Courier" pitchFamily="2" charset="0"/>
+                <a:latin typeface="Menlo" panose="020B0609030804020204" pitchFamily="49" charset="0"/>
+                <a:ea typeface="Menlo" panose="020B0609030804020204" pitchFamily="49" charset="0"/>
+                <a:cs typeface="Menlo" panose="020B0609030804020204" pitchFamily="49" charset="0"/>
               </a:rPr>
               <a:t>  Widget </a:t>
             </a:r>
             <a:r>
               <a:rPr lang="en-GB" sz="1600" b="1" dirty="0">
-                <a:latin typeface="Courier" pitchFamily="2" charset="0"/>
+                <a:latin typeface="Menlo" panose="020B0609030804020204" pitchFamily="49" charset="0"/>
+                <a:ea typeface="Menlo" panose="020B0609030804020204" pitchFamily="49" charset="0"/>
+                <a:cs typeface="Menlo" panose="020B0609030804020204" pitchFamily="49" charset="0"/>
               </a:rPr>
               <a:t>build</a:t>
             </a:r>
             <a:r>
               <a:rPr lang="en-GB" sz="1600" dirty="0">
-                <a:latin typeface="Courier" pitchFamily="2" charset="0"/>
+                <a:latin typeface="Menlo" panose="020B0609030804020204" pitchFamily="49" charset="0"/>
+                <a:ea typeface="Menlo" panose="020B0609030804020204" pitchFamily="49" charset="0"/>
+                <a:cs typeface="Menlo" panose="020B0609030804020204" pitchFamily="49" charset="0"/>
               </a:rPr>
               <a:t>(</a:t>
             </a:r>
             <a:r>
               <a:rPr lang="en-GB" sz="1600" dirty="0" err="1">
-                <a:latin typeface="Courier" pitchFamily="2" charset="0"/>
+                <a:latin typeface="Menlo" panose="020B0609030804020204" pitchFamily="49" charset="0"/>
+                <a:ea typeface="Menlo" panose="020B0609030804020204" pitchFamily="49" charset="0"/>
+                <a:cs typeface="Menlo" panose="020B0609030804020204" pitchFamily="49" charset="0"/>
               </a:rPr>
               <a:t>BuildContext</a:t>
             </a:r>
             <a:r>
               <a:rPr lang="en-GB" sz="1600" dirty="0">
-                <a:latin typeface="Courier" pitchFamily="2" charset="0"/>
+                <a:latin typeface="Menlo" panose="020B0609030804020204" pitchFamily="49" charset="0"/>
+                <a:ea typeface="Menlo" panose="020B0609030804020204" pitchFamily="49" charset="0"/>
+                <a:cs typeface="Menlo" panose="020B0609030804020204" pitchFamily="49" charset="0"/>
               </a:rPr>
               <a:t> context) {</a:t>
             </a:r>
@@ -7322,19 +7597,25 @@
           <a:p>
             <a:r>
               <a:rPr lang="en-GB" sz="1600" dirty="0">
-                <a:latin typeface="Courier" pitchFamily="2" charset="0"/>
+                <a:latin typeface="Menlo" panose="020B0609030804020204" pitchFamily="49" charset="0"/>
+                <a:ea typeface="Menlo" panose="020B0609030804020204" pitchFamily="49" charset="0"/>
+                <a:cs typeface="Menlo" panose="020B0609030804020204" pitchFamily="49" charset="0"/>
               </a:rPr>
               <a:t>    return </a:t>
             </a:r>
             <a:r>
               <a:rPr lang="en-GB" sz="1600" b="1" dirty="0" err="1">
-                <a:latin typeface="Courier" pitchFamily="2" charset="0"/>
+                <a:latin typeface="Menlo" panose="020B0609030804020204" pitchFamily="49" charset="0"/>
+                <a:ea typeface="Menlo" panose="020B0609030804020204" pitchFamily="49" charset="0"/>
+                <a:cs typeface="Menlo" panose="020B0609030804020204" pitchFamily="49" charset="0"/>
               </a:rPr>
               <a:t>MaterialApp</a:t>
             </a:r>
             <a:r>
               <a:rPr lang="en-GB" sz="1600" dirty="0">
-                <a:latin typeface="Courier" pitchFamily="2" charset="0"/>
+                <a:latin typeface="Menlo" panose="020B0609030804020204" pitchFamily="49" charset="0"/>
+                <a:ea typeface="Menlo" panose="020B0609030804020204" pitchFamily="49" charset="0"/>
+                <a:cs typeface="Menlo" panose="020B0609030804020204" pitchFamily="49" charset="0"/>
               </a:rPr>
               <a:t>(</a:t>
             </a:r>
@@ -7342,7 +7623,9 @@
           <a:p>
             <a:r>
               <a:rPr lang="en-GB" sz="1600" dirty="0">
-                <a:latin typeface="Courier" pitchFamily="2" charset="0"/>
+                <a:latin typeface="Menlo" panose="020B0609030804020204" pitchFamily="49" charset="0"/>
+                <a:ea typeface="Menlo" panose="020B0609030804020204" pitchFamily="49" charset="0"/>
+                <a:cs typeface="Menlo" panose="020B0609030804020204" pitchFamily="49" charset="0"/>
               </a:rPr>
               <a:t>      title: 'Welcome to Flutter’,</a:t>
             </a:r>
@@ -7350,19 +7633,25 @@
           <a:p>
             <a:r>
               <a:rPr lang="en-GB" sz="1600" dirty="0">
-                <a:latin typeface="Courier" pitchFamily="2" charset="0"/>
+                <a:latin typeface="Menlo" panose="020B0609030804020204" pitchFamily="49" charset="0"/>
+                <a:ea typeface="Menlo" panose="020B0609030804020204" pitchFamily="49" charset="0"/>
+                <a:cs typeface="Menlo" panose="020B0609030804020204" pitchFamily="49" charset="0"/>
               </a:rPr>
               <a:t>      home: </a:t>
             </a:r>
             <a:r>
               <a:rPr lang="en-GB" sz="1600" b="1" dirty="0">
-                <a:latin typeface="Courier" pitchFamily="2" charset="0"/>
+                <a:latin typeface="Menlo" panose="020B0609030804020204" pitchFamily="49" charset="0"/>
+                <a:ea typeface="Menlo" panose="020B0609030804020204" pitchFamily="49" charset="0"/>
+                <a:cs typeface="Menlo" panose="020B0609030804020204" pitchFamily="49" charset="0"/>
               </a:rPr>
               <a:t>Scaffold</a:t>
             </a:r>
             <a:r>
               <a:rPr lang="en-GB" sz="1600" dirty="0">
-                <a:latin typeface="Courier" pitchFamily="2" charset="0"/>
+                <a:latin typeface="Menlo" panose="020B0609030804020204" pitchFamily="49" charset="0"/>
+                <a:ea typeface="Menlo" panose="020B0609030804020204" pitchFamily="49" charset="0"/>
+                <a:cs typeface="Menlo" panose="020B0609030804020204" pitchFamily="49" charset="0"/>
               </a:rPr>
               <a:t>(</a:t>
             </a:r>
@@ -7370,43 +7659,57 @@
           <a:p>
             <a:r>
               <a:rPr lang="en-GB" sz="1600" dirty="0">
-                <a:latin typeface="Courier" pitchFamily="2" charset="0"/>
+                <a:latin typeface="Menlo" panose="020B0609030804020204" pitchFamily="49" charset="0"/>
+                <a:ea typeface="Menlo" panose="020B0609030804020204" pitchFamily="49" charset="0"/>
+                <a:cs typeface="Menlo" panose="020B0609030804020204" pitchFamily="49" charset="0"/>
               </a:rPr>
               <a:t>      </a:t>
             </a:r>
             <a:r>
               <a:rPr lang="en-GB" sz="1600" dirty="0" err="1">
-                <a:latin typeface="Courier" pitchFamily="2" charset="0"/>
+                <a:latin typeface="Menlo" panose="020B0609030804020204" pitchFamily="49" charset="0"/>
+                <a:ea typeface="Menlo" panose="020B0609030804020204" pitchFamily="49" charset="0"/>
+                <a:cs typeface="Menlo" panose="020B0609030804020204" pitchFamily="49" charset="0"/>
               </a:rPr>
               <a:t>appBar</a:t>
             </a:r>
             <a:r>
               <a:rPr lang="en-GB" sz="1600" dirty="0">
-                <a:latin typeface="Courier" pitchFamily="2" charset="0"/>
+                <a:latin typeface="Menlo" panose="020B0609030804020204" pitchFamily="49" charset="0"/>
+                <a:ea typeface="Menlo" panose="020B0609030804020204" pitchFamily="49" charset="0"/>
+                <a:cs typeface="Menlo" panose="020B0609030804020204" pitchFamily="49" charset="0"/>
               </a:rPr>
               <a:t>: </a:t>
             </a:r>
             <a:r>
               <a:rPr lang="en-GB" sz="1600" b="1" dirty="0" err="1">
-                <a:latin typeface="Courier" pitchFamily="2" charset="0"/>
+                <a:latin typeface="Menlo" panose="020B0609030804020204" pitchFamily="49" charset="0"/>
+                <a:ea typeface="Menlo" panose="020B0609030804020204" pitchFamily="49" charset="0"/>
+                <a:cs typeface="Menlo" panose="020B0609030804020204" pitchFamily="49" charset="0"/>
               </a:rPr>
               <a:t>AppBar</a:t>
             </a:r>
             <a:r>
               <a:rPr lang="en-GB" sz="1600" dirty="0">
-                <a:latin typeface="Courier" pitchFamily="2" charset="0"/>
+                <a:latin typeface="Menlo" panose="020B0609030804020204" pitchFamily="49" charset="0"/>
+                <a:ea typeface="Menlo" panose="020B0609030804020204" pitchFamily="49" charset="0"/>
+                <a:cs typeface="Menlo" panose="020B0609030804020204" pitchFamily="49" charset="0"/>
               </a:rPr>
               <a:t>(title: </a:t>
             </a:r>
             <a:r>
               <a:rPr lang="en-GB" sz="1600" b="1" dirty="0">
-                <a:latin typeface="Courier" pitchFamily="2" charset="0"/>
+                <a:latin typeface="Menlo" panose="020B0609030804020204" pitchFamily="49" charset="0"/>
+                <a:ea typeface="Menlo" panose="020B0609030804020204" pitchFamily="49" charset="0"/>
+                <a:cs typeface="Menlo" panose="020B0609030804020204" pitchFamily="49" charset="0"/>
               </a:rPr>
               <a:t>Text</a:t>
             </a:r>
             <a:r>
               <a:rPr lang="en-GB" sz="1600" dirty="0">
-                <a:latin typeface="Courier" pitchFamily="2" charset="0"/>
+                <a:latin typeface="Menlo" panose="020B0609030804020204" pitchFamily="49" charset="0"/>
+                <a:ea typeface="Menlo" panose="020B0609030804020204" pitchFamily="49" charset="0"/>
+                <a:cs typeface="Menlo" panose="020B0609030804020204" pitchFamily="49" charset="0"/>
               </a:rPr>
               <a:t>('Welcome to Flutter'),),</a:t>
             </a:r>
@@ -7414,31 +7717,41 @@
           <a:p>
             <a:r>
               <a:rPr lang="en-GB" sz="1600" dirty="0">
-                <a:latin typeface="Courier" pitchFamily="2" charset="0"/>
+                <a:latin typeface="Menlo" panose="020B0609030804020204" pitchFamily="49" charset="0"/>
+                <a:ea typeface="Menlo" panose="020B0609030804020204" pitchFamily="49" charset="0"/>
+                <a:cs typeface="Menlo" panose="020B0609030804020204" pitchFamily="49" charset="0"/>
               </a:rPr>
               <a:t>      body: </a:t>
             </a:r>
             <a:r>
               <a:rPr lang="en-GB" sz="1600" b="1" dirty="0" err="1">
-                <a:latin typeface="Courier" pitchFamily="2" charset="0"/>
+                <a:latin typeface="Menlo" panose="020B0609030804020204" pitchFamily="49" charset="0"/>
+                <a:ea typeface="Menlo" panose="020B0609030804020204" pitchFamily="49" charset="0"/>
+                <a:cs typeface="Menlo" panose="020B0609030804020204" pitchFamily="49" charset="0"/>
               </a:rPr>
               <a:t>Center</a:t>
             </a:r>
             <a:r>
               <a:rPr lang="en-GB" sz="1600" dirty="0">
-                <a:latin typeface="Courier" pitchFamily="2" charset="0"/>
+                <a:latin typeface="Menlo" panose="020B0609030804020204" pitchFamily="49" charset="0"/>
+                <a:ea typeface="Menlo" panose="020B0609030804020204" pitchFamily="49" charset="0"/>
+                <a:cs typeface="Menlo" panose="020B0609030804020204" pitchFamily="49" charset="0"/>
               </a:rPr>
               <a:t>(child: </a:t>
             </a:r>
             <a:r>
               <a:rPr lang="en-GB" sz="1600" b="1" dirty="0">
-                <a:latin typeface="Courier" pitchFamily="2" charset="0"/>
+                <a:latin typeface="Menlo" panose="020B0609030804020204" pitchFamily="49" charset="0"/>
+                <a:ea typeface="Menlo" panose="020B0609030804020204" pitchFamily="49" charset="0"/>
+                <a:cs typeface="Menlo" panose="020B0609030804020204" pitchFamily="49" charset="0"/>
               </a:rPr>
               <a:t>Text</a:t>
             </a:r>
             <a:r>
               <a:rPr lang="en-GB" sz="1600" dirty="0">
-                <a:latin typeface="Courier" pitchFamily="2" charset="0"/>
+                <a:latin typeface="Menlo" panose="020B0609030804020204" pitchFamily="49" charset="0"/>
+                <a:ea typeface="Menlo" panose="020B0609030804020204" pitchFamily="49" charset="0"/>
+                <a:cs typeface="Menlo" panose="020B0609030804020204" pitchFamily="49" charset="0"/>
               </a:rPr>
               <a:t>('Hello World'),),),</a:t>
             </a:r>
@@ -7446,7 +7759,9 @@
           <a:p>
             <a:r>
               <a:rPr lang="en-GB" sz="1600" dirty="0">
-                <a:latin typeface="Courier" pitchFamily="2" charset="0"/>
+                <a:latin typeface="Menlo" panose="020B0609030804020204" pitchFamily="49" charset="0"/>
+                <a:ea typeface="Menlo" panose="020B0609030804020204" pitchFamily="49" charset="0"/>
+                <a:cs typeface="Menlo" panose="020B0609030804020204" pitchFamily="49" charset="0"/>
               </a:rPr>
               <a:t>    );</a:t>
             </a:r>
@@ -7454,7 +7769,9 @@
           <a:p>
             <a:r>
               <a:rPr lang="en-GB" sz="1600" dirty="0">
-                <a:latin typeface="Courier" pitchFamily="2" charset="0"/>
+                <a:latin typeface="Menlo" panose="020B0609030804020204" pitchFamily="49" charset="0"/>
+                <a:ea typeface="Menlo" panose="020B0609030804020204" pitchFamily="49" charset="0"/>
+                <a:cs typeface="Menlo" panose="020B0609030804020204" pitchFamily="49" charset="0"/>
               </a:rPr>
               <a:t>  }//build</a:t>
             </a:r>
@@ -7462,18 +7779,24 @@
           <a:p>
             <a:r>
               <a:rPr lang="en-GB" sz="1600" dirty="0">
-                <a:latin typeface="Courier" pitchFamily="2" charset="0"/>
+                <a:latin typeface="Menlo" panose="020B0609030804020204" pitchFamily="49" charset="0"/>
+                <a:ea typeface="Menlo" panose="020B0609030804020204" pitchFamily="49" charset="0"/>
+                <a:cs typeface="Menlo" panose="020B0609030804020204" pitchFamily="49" charset="0"/>
               </a:rPr>
               <a:t>}//</a:t>
             </a:r>
             <a:r>
               <a:rPr lang="en-GB" sz="1600" dirty="0" err="1">
-                <a:latin typeface="Courier" pitchFamily="2" charset="0"/>
+                <a:latin typeface="Menlo" panose="020B0609030804020204" pitchFamily="49" charset="0"/>
+                <a:ea typeface="Menlo" panose="020B0609030804020204" pitchFamily="49" charset="0"/>
+                <a:cs typeface="Menlo" panose="020B0609030804020204" pitchFamily="49" charset="0"/>
               </a:rPr>
               <a:t>MyApp</a:t>
             </a:r>
             <a:endParaRPr lang="en-GB" sz="1600" dirty="0">
-              <a:latin typeface="Courier" pitchFamily="2" charset="0"/>
+              <a:latin typeface="Menlo" panose="020B0609030804020204" pitchFamily="49" charset="0"/>
+              <a:ea typeface="Menlo" panose="020B0609030804020204" pitchFamily="49" charset="0"/>
+              <a:cs typeface="Menlo" panose="020B0609030804020204" pitchFamily="49" charset="0"/>
             </a:endParaRPr>
           </a:p>
         </p:txBody>
@@ -7896,7 +8219,15 @@
           <a:p>
             <a:r>
               <a:rPr lang="en-US" dirty="0"/>
-              <a:t>In bold the Widgets of our app</a:t>
+              <a:t>In </a:t>
+            </a:r>
+            <a:r>
+              <a:rPr lang="en-US" b="1" dirty="0"/>
+              <a:t>bold</a:t>
+            </a:r>
+            <a:r>
+              <a:rPr lang="en-US" dirty="0"/>
+              <a:t> the Widgets of our app</a:t>
             </a:r>
           </a:p>
           <a:p>
@@ -7934,42 +8265,56 @@
           <a:p>
             <a:r>
               <a:rPr lang="en-GB" sz="1600" dirty="0">
-                <a:latin typeface="Courier" pitchFamily="2" charset="0"/>
+                <a:latin typeface="Menlo" panose="020B0609030804020204" pitchFamily="49" charset="0"/>
+                <a:ea typeface="Menlo" panose="020B0609030804020204" pitchFamily="49" charset="0"/>
+                <a:cs typeface="Menlo" panose="020B0609030804020204" pitchFamily="49" charset="0"/>
               </a:rPr>
               <a:t>import '</a:t>
             </a:r>
             <a:r>
               <a:rPr lang="en-GB" sz="1600" dirty="0" err="1">
-                <a:latin typeface="Courier" pitchFamily="2" charset="0"/>
+                <a:latin typeface="Menlo" panose="020B0609030804020204" pitchFamily="49" charset="0"/>
+                <a:ea typeface="Menlo" panose="020B0609030804020204" pitchFamily="49" charset="0"/>
+                <a:cs typeface="Menlo" panose="020B0609030804020204" pitchFamily="49" charset="0"/>
               </a:rPr>
               <a:t>package:flutter</a:t>
             </a:r>
             <a:r>
               <a:rPr lang="en-GB" sz="1600" dirty="0">
-                <a:latin typeface="Courier" pitchFamily="2" charset="0"/>
+                <a:latin typeface="Menlo" panose="020B0609030804020204" pitchFamily="49" charset="0"/>
+                <a:ea typeface="Menlo" panose="020B0609030804020204" pitchFamily="49" charset="0"/>
+                <a:cs typeface="Menlo" panose="020B0609030804020204" pitchFamily="49" charset="0"/>
               </a:rPr>
               <a:t>/</a:t>
             </a:r>
             <a:r>
               <a:rPr lang="en-GB" sz="1600" dirty="0" err="1">
-                <a:latin typeface="Courier" pitchFamily="2" charset="0"/>
+                <a:latin typeface="Menlo" panose="020B0609030804020204" pitchFamily="49" charset="0"/>
+                <a:ea typeface="Menlo" panose="020B0609030804020204" pitchFamily="49" charset="0"/>
+                <a:cs typeface="Menlo" panose="020B0609030804020204" pitchFamily="49" charset="0"/>
               </a:rPr>
               <a:t>material.dart</a:t>
             </a:r>
             <a:r>
               <a:rPr lang="en-GB" sz="1600" dirty="0">
-                <a:latin typeface="Courier" pitchFamily="2" charset="0"/>
+                <a:latin typeface="Menlo" panose="020B0609030804020204" pitchFamily="49" charset="0"/>
+                <a:ea typeface="Menlo" panose="020B0609030804020204" pitchFamily="49" charset="0"/>
+                <a:cs typeface="Menlo" panose="020B0609030804020204" pitchFamily="49" charset="0"/>
               </a:rPr>
               <a:t>';</a:t>
             </a:r>
             <a:br>
               <a:rPr lang="en-GB" sz="1600" dirty="0">
-                <a:latin typeface="Courier" pitchFamily="2" charset="0"/>
+                <a:latin typeface="Menlo" panose="020B0609030804020204" pitchFamily="49" charset="0"/>
+                <a:ea typeface="Menlo" panose="020B0609030804020204" pitchFamily="49" charset="0"/>
+                <a:cs typeface="Menlo" panose="020B0609030804020204" pitchFamily="49" charset="0"/>
               </a:rPr>
             </a:br>
             <a:r>
               <a:rPr lang="en-GB" sz="1600" dirty="0">
-                <a:latin typeface="Courier" pitchFamily="2" charset="0"/>
+                <a:latin typeface="Menlo" panose="020B0609030804020204" pitchFamily="49" charset="0"/>
+                <a:ea typeface="Menlo" panose="020B0609030804020204" pitchFamily="49" charset="0"/>
+                <a:cs typeface="Menlo" panose="020B0609030804020204" pitchFamily="49" charset="0"/>
               </a:rPr>
               <a:t>void main() {</a:t>
             </a:r>
@@ -7977,31 +8322,41 @@
           <a:p>
             <a:r>
               <a:rPr lang="en-GB" sz="1600" dirty="0">
-                <a:latin typeface="Courier" pitchFamily="2" charset="0"/>
+                <a:latin typeface="Menlo" panose="020B0609030804020204" pitchFamily="49" charset="0"/>
+                <a:ea typeface="Menlo" panose="020B0609030804020204" pitchFamily="49" charset="0"/>
+                <a:cs typeface="Menlo" panose="020B0609030804020204" pitchFamily="49" charset="0"/>
               </a:rPr>
               <a:t>  </a:t>
             </a:r>
             <a:r>
               <a:rPr lang="en-GB" sz="1600" dirty="0" err="1">
-                <a:latin typeface="Courier" pitchFamily="2" charset="0"/>
+                <a:latin typeface="Menlo" panose="020B0609030804020204" pitchFamily="49" charset="0"/>
+                <a:ea typeface="Menlo" panose="020B0609030804020204" pitchFamily="49" charset="0"/>
+                <a:cs typeface="Menlo" panose="020B0609030804020204" pitchFamily="49" charset="0"/>
               </a:rPr>
               <a:t>runApp</a:t>
             </a:r>
             <a:r>
               <a:rPr lang="en-GB" sz="1600" dirty="0">
-                <a:latin typeface="Courier" pitchFamily="2" charset="0"/>
+                <a:latin typeface="Menlo" panose="020B0609030804020204" pitchFamily="49" charset="0"/>
+                <a:ea typeface="Menlo" panose="020B0609030804020204" pitchFamily="49" charset="0"/>
+                <a:cs typeface="Menlo" panose="020B0609030804020204" pitchFamily="49" charset="0"/>
               </a:rPr>
               <a:t>(</a:t>
             </a:r>
             <a:r>
               <a:rPr lang="en-GB" sz="1600" b="1" dirty="0" err="1">
-                <a:latin typeface="Courier" pitchFamily="2" charset="0"/>
+                <a:latin typeface="Menlo" panose="020B0609030804020204" pitchFamily="49" charset="0"/>
+                <a:ea typeface="Menlo" panose="020B0609030804020204" pitchFamily="49" charset="0"/>
+                <a:cs typeface="Menlo" panose="020B0609030804020204" pitchFamily="49" charset="0"/>
               </a:rPr>
               <a:t>MyApp</a:t>
             </a:r>
             <a:r>
               <a:rPr lang="en-GB" sz="1600" dirty="0">
-                <a:latin typeface="Courier" pitchFamily="2" charset="0"/>
+                <a:latin typeface="Menlo" panose="020B0609030804020204" pitchFamily="49" charset="0"/>
+                <a:ea typeface="Menlo" panose="020B0609030804020204" pitchFamily="49" charset="0"/>
+                <a:cs typeface="Menlo" panose="020B0609030804020204" pitchFamily="49" charset="0"/>
               </a:rPr>
               <a:t>());</a:t>
             </a:r>
@@ -8009,42 +8364,56 @@
           <a:p>
             <a:r>
               <a:rPr lang="en-GB" sz="1600" dirty="0">
-                <a:latin typeface="Courier" pitchFamily="2" charset="0"/>
+                <a:latin typeface="Menlo" panose="020B0609030804020204" pitchFamily="49" charset="0"/>
+                <a:ea typeface="Menlo" panose="020B0609030804020204" pitchFamily="49" charset="0"/>
+                <a:cs typeface="Menlo" panose="020B0609030804020204" pitchFamily="49" charset="0"/>
               </a:rPr>
               <a:t>}//main</a:t>
             </a:r>
             <a:br>
               <a:rPr lang="en-GB" sz="1600" dirty="0">
-                <a:latin typeface="Courier" pitchFamily="2" charset="0"/>
+                <a:latin typeface="Menlo" panose="020B0609030804020204" pitchFamily="49" charset="0"/>
+                <a:ea typeface="Menlo" panose="020B0609030804020204" pitchFamily="49" charset="0"/>
+                <a:cs typeface="Menlo" panose="020B0609030804020204" pitchFamily="49" charset="0"/>
               </a:rPr>
             </a:br>
             <a:r>
               <a:rPr lang="en-GB" sz="1600" dirty="0">
-                <a:latin typeface="Courier" pitchFamily="2" charset="0"/>
+                <a:latin typeface="Menlo" panose="020B0609030804020204" pitchFamily="49" charset="0"/>
+                <a:ea typeface="Menlo" panose="020B0609030804020204" pitchFamily="49" charset="0"/>
+                <a:cs typeface="Menlo" panose="020B0609030804020204" pitchFamily="49" charset="0"/>
               </a:rPr>
               <a:t>class </a:t>
             </a:r>
             <a:r>
               <a:rPr lang="en-GB" sz="1600" dirty="0" err="1">
-                <a:latin typeface="Courier" pitchFamily="2" charset="0"/>
+                <a:latin typeface="Menlo" panose="020B0609030804020204" pitchFamily="49" charset="0"/>
+                <a:ea typeface="Menlo" panose="020B0609030804020204" pitchFamily="49" charset="0"/>
+                <a:cs typeface="Menlo" panose="020B0609030804020204" pitchFamily="49" charset="0"/>
               </a:rPr>
               <a:t>MyApp</a:t>
             </a:r>
             <a:r>
               <a:rPr lang="en-GB" sz="1600" dirty="0">
-                <a:latin typeface="Courier" pitchFamily="2" charset="0"/>
+                <a:latin typeface="Menlo" panose="020B0609030804020204" pitchFamily="49" charset="0"/>
+                <a:ea typeface="Menlo" panose="020B0609030804020204" pitchFamily="49" charset="0"/>
+                <a:cs typeface="Menlo" panose="020B0609030804020204" pitchFamily="49" charset="0"/>
               </a:rPr>
               <a:t> extends </a:t>
             </a:r>
             <a:r>
               <a:rPr lang="en-GB" sz="1600" dirty="0" err="1">
-                <a:latin typeface="Courier" pitchFamily="2" charset="0"/>
+                <a:latin typeface="Menlo" panose="020B0609030804020204" pitchFamily="49" charset="0"/>
+                <a:ea typeface="Menlo" panose="020B0609030804020204" pitchFamily="49" charset="0"/>
+                <a:cs typeface="Menlo" panose="020B0609030804020204" pitchFamily="49" charset="0"/>
               </a:rPr>
               <a:t>StatelessWidget</a:t>
             </a:r>
             <a:r>
               <a:rPr lang="en-GB" sz="1600" dirty="0">
-                <a:latin typeface="Courier" pitchFamily="2" charset="0"/>
+                <a:latin typeface="Menlo" panose="020B0609030804020204" pitchFamily="49" charset="0"/>
+                <a:ea typeface="Menlo" panose="020B0609030804020204" pitchFamily="49" charset="0"/>
+                <a:cs typeface="Menlo" panose="020B0609030804020204" pitchFamily="49" charset="0"/>
               </a:rPr>
               <a:t> {</a:t>
             </a:r>
@@ -8052,19 +8421,25 @@
           <a:p>
             <a:r>
               <a:rPr lang="en-GB" sz="1600" dirty="0">
-                <a:latin typeface="Courier" pitchFamily="2" charset="0"/>
+                <a:latin typeface="Menlo" panose="020B0609030804020204" pitchFamily="49" charset="0"/>
+                <a:ea typeface="Menlo" panose="020B0609030804020204" pitchFamily="49" charset="0"/>
+                <a:cs typeface="Menlo" panose="020B0609030804020204" pitchFamily="49" charset="0"/>
               </a:rPr>
               <a:t>  </a:t>
             </a:r>
             <a:r>
               <a:rPr lang="en-GB" sz="1600" dirty="0" err="1">
-                <a:latin typeface="Courier" pitchFamily="2" charset="0"/>
+                <a:latin typeface="Menlo" panose="020B0609030804020204" pitchFamily="49" charset="0"/>
+                <a:ea typeface="Menlo" panose="020B0609030804020204" pitchFamily="49" charset="0"/>
+                <a:cs typeface="Menlo" panose="020B0609030804020204" pitchFamily="49" charset="0"/>
               </a:rPr>
               <a:t>MyApp</a:t>
             </a:r>
             <a:r>
               <a:rPr lang="en-GB" sz="1600" dirty="0">
-                <a:latin typeface="Courier" pitchFamily="2" charset="0"/>
+                <a:latin typeface="Menlo" panose="020B0609030804020204" pitchFamily="49" charset="0"/>
+                <a:ea typeface="Menlo" panose="020B0609030804020204" pitchFamily="49" charset="0"/>
+                <a:cs typeface="Menlo" panose="020B0609030804020204" pitchFamily="49" charset="0"/>
               </a:rPr>
               <a:t>({Key? key}) : super(key: key);</a:t>
             </a:r>
@@ -8072,12 +8447,16 @@
           <a:p>
             <a:br>
               <a:rPr lang="en-GB" sz="1600" dirty="0">
-                <a:latin typeface="Courier" pitchFamily="2" charset="0"/>
+                <a:latin typeface="Menlo" panose="020B0609030804020204" pitchFamily="49" charset="0"/>
+                <a:ea typeface="Menlo" panose="020B0609030804020204" pitchFamily="49" charset="0"/>
+                <a:cs typeface="Menlo" panose="020B0609030804020204" pitchFamily="49" charset="0"/>
               </a:rPr>
             </a:br>
             <a:r>
               <a:rPr lang="en-GB" sz="1600" dirty="0">
-                <a:latin typeface="Courier" pitchFamily="2" charset="0"/>
+                <a:latin typeface="Menlo" panose="020B0609030804020204" pitchFamily="49" charset="0"/>
+                <a:ea typeface="Menlo" panose="020B0609030804020204" pitchFamily="49" charset="0"/>
+                <a:cs typeface="Menlo" panose="020B0609030804020204" pitchFamily="49" charset="0"/>
               </a:rPr>
               <a:t>  @override</a:t>
             </a:r>
@@ -8085,31 +8464,41 @@
           <a:p>
             <a:r>
               <a:rPr lang="en-GB" sz="1600" dirty="0">
-                <a:latin typeface="Courier" pitchFamily="2" charset="0"/>
+                <a:latin typeface="Menlo" panose="020B0609030804020204" pitchFamily="49" charset="0"/>
+                <a:ea typeface="Menlo" panose="020B0609030804020204" pitchFamily="49" charset="0"/>
+                <a:cs typeface="Menlo" panose="020B0609030804020204" pitchFamily="49" charset="0"/>
               </a:rPr>
               <a:t>  Widget </a:t>
             </a:r>
             <a:r>
               <a:rPr lang="en-GB" sz="1600" b="1" dirty="0">
-                <a:latin typeface="Courier" pitchFamily="2" charset="0"/>
+                <a:latin typeface="Menlo" panose="020B0609030804020204" pitchFamily="49" charset="0"/>
+                <a:ea typeface="Menlo" panose="020B0609030804020204" pitchFamily="49" charset="0"/>
+                <a:cs typeface="Menlo" panose="020B0609030804020204" pitchFamily="49" charset="0"/>
               </a:rPr>
               <a:t>build</a:t>
             </a:r>
             <a:r>
               <a:rPr lang="en-GB" sz="1600" dirty="0">
-                <a:latin typeface="Courier" pitchFamily="2" charset="0"/>
+                <a:latin typeface="Menlo" panose="020B0609030804020204" pitchFamily="49" charset="0"/>
+                <a:ea typeface="Menlo" panose="020B0609030804020204" pitchFamily="49" charset="0"/>
+                <a:cs typeface="Menlo" panose="020B0609030804020204" pitchFamily="49" charset="0"/>
               </a:rPr>
               <a:t>(</a:t>
             </a:r>
             <a:r>
               <a:rPr lang="en-GB" sz="1600" dirty="0" err="1">
-                <a:latin typeface="Courier" pitchFamily="2" charset="0"/>
+                <a:latin typeface="Menlo" panose="020B0609030804020204" pitchFamily="49" charset="0"/>
+                <a:ea typeface="Menlo" panose="020B0609030804020204" pitchFamily="49" charset="0"/>
+                <a:cs typeface="Menlo" panose="020B0609030804020204" pitchFamily="49" charset="0"/>
               </a:rPr>
               <a:t>BuildContext</a:t>
             </a:r>
             <a:r>
               <a:rPr lang="en-GB" sz="1600" dirty="0">
-                <a:latin typeface="Courier" pitchFamily="2" charset="0"/>
+                <a:latin typeface="Menlo" panose="020B0609030804020204" pitchFamily="49" charset="0"/>
+                <a:ea typeface="Menlo" panose="020B0609030804020204" pitchFamily="49" charset="0"/>
+                <a:cs typeface="Menlo" panose="020B0609030804020204" pitchFamily="49" charset="0"/>
               </a:rPr>
               <a:t> context) {</a:t>
             </a:r>
@@ -8117,19 +8506,25 @@
           <a:p>
             <a:r>
               <a:rPr lang="en-GB" sz="1600" dirty="0">
-                <a:latin typeface="Courier" pitchFamily="2" charset="0"/>
+                <a:latin typeface="Menlo" panose="020B0609030804020204" pitchFamily="49" charset="0"/>
+                <a:ea typeface="Menlo" panose="020B0609030804020204" pitchFamily="49" charset="0"/>
+                <a:cs typeface="Menlo" panose="020B0609030804020204" pitchFamily="49" charset="0"/>
               </a:rPr>
               <a:t>    return </a:t>
             </a:r>
             <a:r>
               <a:rPr lang="en-GB" sz="1600" b="1" dirty="0" err="1">
-                <a:latin typeface="Courier" pitchFamily="2" charset="0"/>
+                <a:latin typeface="Menlo" panose="020B0609030804020204" pitchFamily="49" charset="0"/>
+                <a:ea typeface="Menlo" panose="020B0609030804020204" pitchFamily="49" charset="0"/>
+                <a:cs typeface="Menlo" panose="020B0609030804020204" pitchFamily="49" charset="0"/>
               </a:rPr>
               <a:t>MaterialApp</a:t>
             </a:r>
             <a:r>
               <a:rPr lang="en-GB" sz="1600" dirty="0">
-                <a:latin typeface="Courier" pitchFamily="2" charset="0"/>
+                <a:latin typeface="Menlo" panose="020B0609030804020204" pitchFamily="49" charset="0"/>
+                <a:ea typeface="Menlo" panose="020B0609030804020204" pitchFamily="49" charset="0"/>
+                <a:cs typeface="Menlo" panose="020B0609030804020204" pitchFamily="49" charset="0"/>
               </a:rPr>
               <a:t>(</a:t>
             </a:r>
@@ -8137,7 +8532,9 @@
           <a:p>
             <a:r>
               <a:rPr lang="en-GB" sz="1600" dirty="0">
-                <a:latin typeface="Courier" pitchFamily="2" charset="0"/>
+                <a:latin typeface="Menlo" panose="020B0609030804020204" pitchFamily="49" charset="0"/>
+                <a:ea typeface="Menlo" panose="020B0609030804020204" pitchFamily="49" charset="0"/>
+                <a:cs typeface="Menlo" panose="020B0609030804020204" pitchFamily="49" charset="0"/>
               </a:rPr>
               <a:t>      title: 'Welcome to Flutter’,</a:t>
             </a:r>
@@ -8145,19 +8542,25 @@
           <a:p>
             <a:r>
               <a:rPr lang="en-GB" sz="1600" dirty="0">
-                <a:latin typeface="Courier" pitchFamily="2" charset="0"/>
+                <a:latin typeface="Menlo" panose="020B0609030804020204" pitchFamily="49" charset="0"/>
+                <a:ea typeface="Menlo" panose="020B0609030804020204" pitchFamily="49" charset="0"/>
+                <a:cs typeface="Menlo" panose="020B0609030804020204" pitchFamily="49" charset="0"/>
               </a:rPr>
               <a:t>      home: </a:t>
             </a:r>
             <a:r>
               <a:rPr lang="en-GB" sz="1600" b="1" dirty="0">
-                <a:latin typeface="Courier" pitchFamily="2" charset="0"/>
+                <a:latin typeface="Menlo" panose="020B0609030804020204" pitchFamily="49" charset="0"/>
+                <a:ea typeface="Menlo" panose="020B0609030804020204" pitchFamily="49" charset="0"/>
+                <a:cs typeface="Menlo" panose="020B0609030804020204" pitchFamily="49" charset="0"/>
               </a:rPr>
               <a:t>Scaffold</a:t>
             </a:r>
             <a:r>
               <a:rPr lang="en-GB" sz="1600" dirty="0">
-                <a:latin typeface="Courier" pitchFamily="2" charset="0"/>
+                <a:latin typeface="Menlo" panose="020B0609030804020204" pitchFamily="49" charset="0"/>
+                <a:ea typeface="Menlo" panose="020B0609030804020204" pitchFamily="49" charset="0"/>
+                <a:cs typeface="Menlo" panose="020B0609030804020204" pitchFamily="49" charset="0"/>
               </a:rPr>
               <a:t>(</a:t>
             </a:r>
@@ -8165,43 +8568,57 @@
           <a:p>
             <a:r>
               <a:rPr lang="en-GB" sz="1600" dirty="0">
-                <a:latin typeface="Courier" pitchFamily="2" charset="0"/>
+                <a:latin typeface="Menlo" panose="020B0609030804020204" pitchFamily="49" charset="0"/>
+                <a:ea typeface="Menlo" panose="020B0609030804020204" pitchFamily="49" charset="0"/>
+                <a:cs typeface="Menlo" panose="020B0609030804020204" pitchFamily="49" charset="0"/>
               </a:rPr>
               <a:t>      </a:t>
             </a:r>
             <a:r>
               <a:rPr lang="en-GB" sz="1600" dirty="0" err="1">
-                <a:latin typeface="Courier" pitchFamily="2" charset="0"/>
+                <a:latin typeface="Menlo" panose="020B0609030804020204" pitchFamily="49" charset="0"/>
+                <a:ea typeface="Menlo" panose="020B0609030804020204" pitchFamily="49" charset="0"/>
+                <a:cs typeface="Menlo" panose="020B0609030804020204" pitchFamily="49" charset="0"/>
               </a:rPr>
               <a:t>appBar</a:t>
             </a:r>
             <a:r>
               <a:rPr lang="en-GB" sz="1600" dirty="0">
-                <a:latin typeface="Courier" pitchFamily="2" charset="0"/>
+                <a:latin typeface="Menlo" panose="020B0609030804020204" pitchFamily="49" charset="0"/>
+                <a:ea typeface="Menlo" panose="020B0609030804020204" pitchFamily="49" charset="0"/>
+                <a:cs typeface="Menlo" panose="020B0609030804020204" pitchFamily="49" charset="0"/>
               </a:rPr>
               <a:t>: </a:t>
             </a:r>
             <a:r>
               <a:rPr lang="en-GB" sz="1600" b="1" dirty="0" err="1">
-                <a:latin typeface="Courier" pitchFamily="2" charset="0"/>
+                <a:latin typeface="Menlo" panose="020B0609030804020204" pitchFamily="49" charset="0"/>
+                <a:ea typeface="Menlo" panose="020B0609030804020204" pitchFamily="49" charset="0"/>
+                <a:cs typeface="Menlo" panose="020B0609030804020204" pitchFamily="49" charset="0"/>
               </a:rPr>
               <a:t>AppBar</a:t>
             </a:r>
             <a:r>
               <a:rPr lang="en-GB" sz="1600" dirty="0">
-                <a:latin typeface="Courier" pitchFamily="2" charset="0"/>
+                <a:latin typeface="Menlo" panose="020B0609030804020204" pitchFamily="49" charset="0"/>
+                <a:ea typeface="Menlo" panose="020B0609030804020204" pitchFamily="49" charset="0"/>
+                <a:cs typeface="Menlo" panose="020B0609030804020204" pitchFamily="49" charset="0"/>
               </a:rPr>
               <a:t>(title: </a:t>
             </a:r>
             <a:r>
               <a:rPr lang="en-GB" sz="1600" b="1" dirty="0">
-                <a:latin typeface="Courier" pitchFamily="2" charset="0"/>
+                <a:latin typeface="Menlo" panose="020B0609030804020204" pitchFamily="49" charset="0"/>
+                <a:ea typeface="Menlo" panose="020B0609030804020204" pitchFamily="49" charset="0"/>
+                <a:cs typeface="Menlo" panose="020B0609030804020204" pitchFamily="49" charset="0"/>
               </a:rPr>
               <a:t>Text</a:t>
             </a:r>
             <a:r>
               <a:rPr lang="en-GB" sz="1600" dirty="0">
-                <a:latin typeface="Courier" pitchFamily="2" charset="0"/>
+                <a:latin typeface="Menlo" panose="020B0609030804020204" pitchFamily="49" charset="0"/>
+                <a:ea typeface="Menlo" panose="020B0609030804020204" pitchFamily="49" charset="0"/>
+                <a:cs typeface="Menlo" panose="020B0609030804020204" pitchFamily="49" charset="0"/>
               </a:rPr>
               <a:t>('Welcome to Flutter'),),</a:t>
             </a:r>
@@ -8209,31 +8626,41 @@
           <a:p>
             <a:r>
               <a:rPr lang="en-GB" sz="1600" dirty="0">
-                <a:latin typeface="Courier" pitchFamily="2" charset="0"/>
+                <a:latin typeface="Menlo" panose="020B0609030804020204" pitchFamily="49" charset="0"/>
+                <a:ea typeface="Menlo" panose="020B0609030804020204" pitchFamily="49" charset="0"/>
+                <a:cs typeface="Menlo" panose="020B0609030804020204" pitchFamily="49" charset="0"/>
               </a:rPr>
               <a:t>      body: </a:t>
             </a:r>
             <a:r>
               <a:rPr lang="en-GB" sz="1600" b="1" dirty="0" err="1">
-                <a:latin typeface="Courier" pitchFamily="2" charset="0"/>
+                <a:latin typeface="Menlo" panose="020B0609030804020204" pitchFamily="49" charset="0"/>
+                <a:ea typeface="Menlo" panose="020B0609030804020204" pitchFamily="49" charset="0"/>
+                <a:cs typeface="Menlo" panose="020B0609030804020204" pitchFamily="49" charset="0"/>
               </a:rPr>
               <a:t>Center</a:t>
             </a:r>
             <a:r>
               <a:rPr lang="en-GB" sz="1600" dirty="0">
-                <a:latin typeface="Courier" pitchFamily="2" charset="0"/>
+                <a:latin typeface="Menlo" panose="020B0609030804020204" pitchFamily="49" charset="0"/>
+                <a:ea typeface="Menlo" panose="020B0609030804020204" pitchFamily="49" charset="0"/>
+                <a:cs typeface="Menlo" panose="020B0609030804020204" pitchFamily="49" charset="0"/>
               </a:rPr>
               <a:t>(child: </a:t>
             </a:r>
             <a:r>
               <a:rPr lang="en-GB" sz="1600" b="1" dirty="0">
-                <a:latin typeface="Courier" pitchFamily="2" charset="0"/>
+                <a:latin typeface="Menlo" panose="020B0609030804020204" pitchFamily="49" charset="0"/>
+                <a:ea typeface="Menlo" panose="020B0609030804020204" pitchFamily="49" charset="0"/>
+                <a:cs typeface="Menlo" panose="020B0609030804020204" pitchFamily="49" charset="0"/>
               </a:rPr>
               <a:t>Text</a:t>
             </a:r>
             <a:r>
               <a:rPr lang="en-GB" sz="1600" dirty="0">
-                <a:latin typeface="Courier" pitchFamily="2" charset="0"/>
+                <a:latin typeface="Menlo" panose="020B0609030804020204" pitchFamily="49" charset="0"/>
+                <a:ea typeface="Menlo" panose="020B0609030804020204" pitchFamily="49" charset="0"/>
+                <a:cs typeface="Menlo" panose="020B0609030804020204" pitchFamily="49" charset="0"/>
               </a:rPr>
               <a:t>('Hello World'),),),</a:t>
             </a:r>
@@ -8241,7 +8668,9 @@
           <a:p>
             <a:r>
               <a:rPr lang="en-GB" sz="1600" dirty="0">
-                <a:latin typeface="Courier" pitchFamily="2" charset="0"/>
+                <a:latin typeface="Menlo" panose="020B0609030804020204" pitchFamily="49" charset="0"/>
+                <a:ea typeface="Menlo" panose="020B0609030804020204" pitchFamily="49" charset="0"/>
+                <a:cs typeface="Menlo" panose="020B0609030804020204" pitchFamily="49" charset="0"/>
               </a:rPr>
               <a:t>    );</a:t>
             </a:r>
@@ -8249,7 +8678,9 @@
           <a:p>
             <a:r>
               <a:rPr lang="en-GB" sz="1600" dirty="0">
-                <a:latin typeface="Courier" pitchFamily="2" charset="0"/>
+                <a:latin typeface="Menlo" panose="020B0609030804020204" pitchFamily="49" charset="0"/>
+                <a:ea typeface="Menlo" panose="020B0609030804020204" pitchFamily="49" charset="0"/>
+                <a:cs typeface="Menlo" panose="020B0609030804020204" pitchFamily="49" charset="0"/>
               </a:rPr>
               <a:t>  }//build</a:t>
             </a:r>
@@ -8257,18 +8688,24 @@
           <a:p>
             <a:r>
               <a:rPr lang="en-GB" sz="1600" dirty="0">
-                <a:latin typeface="Courier" pitchFamily="2" charset="0"/>
+                <a:latin typeface="Menlo" panose="020B0609030804020204" pitchFamily="49" charset="0"/>
+                <a:ea typeface="Menlo" panose="020B0609030804020204" pitchFamily="49" charset="0"/>
+                <a:cs typeface="Menlo" panose="020B0609030804020204" pitchFamily="49" charset="0"/>
               </a:rPr>
               <a:t>}//</a:t>
             </a:r>
             <a:r>
               <a:rPr lang="en-GB" sz="1600" dirty="0" err="1">
-                <a:latin typeface="Courier" pitchFamily="2" charset="0"/>
+                <a:latin typeface="Menlo" panose="020B0609030804020204" pitchFamily="49" charset="0"/>
+                <a:ea typeface="Menlo" panose="020B0609030804020204" pitchFamily="49" charset="0"/>
+                <a:cs typeface="Menlo" panose="020B0609030804020204" pitchFamily="49" charset="0"/>
               </a:rPr>
               <a:t>MyApp</a:t>
             </a:r>
             <a:endParaRPr lang="en-GB" sz="1600" dirty="0">
-              <a:latin typeface="Courier" pitchFamily="2" charset="0"/>
+              <a:latin typeface="Menlo" panose="020B0609030804020204" pitchFamily="49" charset="0"/>
+              <a:ea typeface="Menlo" panose="020B0609030804020204" pitchFamily="49" charset="0"/>
+              <a:cs typeface="Menlo" panose="020B0609030804020204" pitchFamily="49" charset="0"/>
             </a:endParaRPr>
           </a:p>
         </p:txBody>
@@ -8355,12 +8792,16 @@
             </a:r>
             <a:r>
               <a:rPr lang="en-GB" dirty="0" err="1">
-                <a:latin typeface="Courier" pitchFamily="2" charset="0"/>
+                <a:latin typeface="Menlo" panose="020B0609030804020204" pitchFamily="49" charset="0"/>
+                <a:ea typeface="Menlo" panose="020B0609030804020204" pitchFamily="49" charset="0"/>
+                <a:cs typeface="Menlo" panose="020B0609030804020204" pitchFamily="49" charset="0"/>
               </a:rPr>
               <a:t>StatelessWidget</a:t>
             </a:r>
             <a:endParaRPr lang="en-IT" dirty="0">
-              <a:latin typeface="Courier" pitchFamily="2" charset="0"/>
+              <a:latin typeface="Menlo" panose="020B0609030804020204" pitchFamily="49" charset="0"/>
+              <a:ea typeface="Menlo" panose="020B0609030804020204" pitchFamily="49" charset="0"/>
+              <a:cs typeface="Menlo" panose="020B0609030804020204" pitchFamily="49" charset="0"/>
             </a:endParaRPr>
           </a:p>
         </p:txBody>
@@ -8482,7 +8923,9 @@
           <a:p>
             <a:r>
               <a:rPr lang="en-GB" b="1" dirty="0" err="1">
-                <a:latin typeface="Courier" pitchFamily="2" charset="0"/>
+                <a:latin typeface="Menlo" panose="020B0609030804020204" pitchFamily="49" charset="0"/>
+                <a:ea typeface="Menlo" panose="020B0609030804020204" pitchFamily="49" charset="0"/>
+                <a:cs typeface="Menlo" panose="020B0609030804020204" pitchFamily="49" charset="0"/>
               </a:rPr>
               <a:t>StatelessWidget</a:t>
             </a:r>
@@ -8501,7 +8944,9 @@
           <a:p>
             <a:r>
               <a:rPr lang="en-GB" b="1" dirty="0" err="1">
-                <a:latin typeface="Courier" pitchFamily="2" charset="0"/>
+                <a:latin typeface="Menlo" panose="020B0609030804020204" pitchFamily="49" charset="0"/>
+                <a:ea typeface="Menlo" panose="020B0609030804020204" pitchFamily="49" charset="0"/>
+                <a:cs typeface="Menlo" panose="020B0609030804020204" pitchFamily="49" charset="0"/>
               </a:rPr>
               <a:t>StatefulWidget</a:t>
             </a:r>
@@ -8521,7 +8966,39 @@
           <a:p>
             <a:r>
               <a:rPr lang="en-IT" dirty="0"/>
-              <a:t>You can think about StatelessWidget as a sort of constant and StatefulWidget as a variable. </a:t>
+              <a:t>You can think about </a:t>
+            </a:r>
+            <a:r>
+              <a:rPr lang="en-IT" dirty="0">
+                <a:latin typeface="Menlo" panose="020B0609030804020204" pitchFamily="49" charset="0"/>
+                <a:ea typeface="Menlo" panose="020B0609030804020204" pitchFamily="49" charset="0"/>
+                <a:cs typeface="Menlo" panose="020B0609030804020204" pitchFamily="49" charset="0"/>
+              </a:rPr>
+              <a:t>StatelessWidget</a:t>
+            </a:r>
+            <a:r>
+              <a:rPr lang="en-IT" dirty="0"/>
+              <a:t> as a sort of constant </a:t>
+            </a:r>
+            <a:r>
+              <a:rPr lang="en-IT"/>
+              <a:t>and </a:t>
+            </a:r>
+            <a:r>
+              <a:rPr lang="en-IT" dirty="0">
+                <a:latin typeface="Menlo" panose="020B0609030804020204" pitchFamily="49" charset="0"/>
+                <a:ea typeface="Menlo" panose="020B0609030804020204" pitchFamily="49" charset="0"/>
+                <a:cs typeface="Menlo" panose="020B0609030804020204" pitchFamily="49" charset="0"/>
+              </a:rPr>
+              <a:t>StatefulWidget</a:t>
+            </a:r>
+            <a:r>
+              <a:rPr lang="en-IT"/>
+              <a:t> </a:t>
+            </a:r>
+            <a:r>
+              <a:rPr lang="en-IT" dirty="0"/>
+              <a:t>as a variable. </a:t>
             </a:r>
           </a:p>
         </p:txBody>
@@ -8735,24 +9212,32 @@
           <a:p>
             <a:r>
               <a:rPr lang="en-GB" sz="1200" dirty="0">
-                <a:latin typeface="Courier" pitchFamily="2" charset="0"/>
+                <a:latin typeface="Menlo" panose="020B0609030804020204" pitchFamily="49" charset="0"/>
+                <a:ea typeface="Menlo" panose="020B0609030804020204" pitchFamily="49" charset="0"/>
+                <a:cs typeface="Menlo" panose="020B0609030804020204" pitchFamily="49" charset="0"/>
               </a:rPr>
               <a:t>name: </a:t>
             </a:r>
             <a:r>
               <a:rPr lang="en-GB" sz="1200" dirty="0" err="1">
-                <a:latin typeface="Courier" pitchFamily="2" charset="0"/>
+                <a:latin typeface="Menlo" panose="020B0609030804020204" pitchFamily="49" charset="0"/>
+                <a:ea typeface="Menlo" panose="020B0609030804020204" pitchFamily="49" charset="0"/>
+                <a:cs typeface="Menlo" panose="020B0609030804020204" pitchFamily="49" charset="0"/>
               </a:rPr>
               <a:t>my_first_app</a:t>
             </a:r>
             <a:endParaRPr lang="en-GB" sz="1200" dirty="0">
-              <a:latin typeface="Courier" pitchFamily="2" charset="0"/>
+              <a:latin typeface="Menlo" panose="020B0609030804020204" pitchFamily="49" charset="0"/>
+              <a:ea typeface="Menlo" panose="020B0609030804020204" pitchFamily="49" charset="0"/>
+              <a:cs typeface="Menlo" panose="020B0609030804020204" pitchFamily="49" charset="0"/>
             </a:endParaRPr>
           </a:p>
           <a:p>
             <a:r>
               <a:rPr lang="en-GB" sz="1200" dirty="0">
-                <a:latin typeface="Courier" pitchFamily="2" charset="0"/>
+                <a:latin typeface="Menlo" panose="020B0609030804020204" pitchFamily="49" charset="0"/>
+                <a:ea typeface="Menlo" panose="020B0609030804020204" pitchFamily="49" charset="0"/>
+                <a:cs typeface="Menlo" panose="020B0609030804020204" pitchFamily="49" charset="0"/>
               </a:rPr>
               <a:t>description: A new Flutter project.</a:t>
             </a:r>
@@ -8760,13 +9245,17 @@
           <a:p>
             <a:r>
               <a:rPr lang="en-GB" sz="1200" dirty="0" err="1">
-                <a:latin typeface="Courier" pitchFamily="2" charset="0"/>
+                <a:latin typeface="Menlo" panose="020B0609030804020204" pitchFamily="49" charset="0"/>
+                <a:ea typeface="Menlo" panose="020B0609030804020204" pitchFamily="49" charset="0"/>
+                <a:cs typeface="Menlo" panose="020B0609030804020204" pitchFamily="49" charset="0"/>
               </a:rPr>
               <a:t>publish_to</a:t>
             </a:r>
             <a:r>
               <a:rPr lang="en-GB" sz="1200" dirty="0">
-                <a:latin typeface="Courier" pitchFamily="2" charset="0"/>
+                <a:latin typeface="Menlo" panose="020B0609030804020204" pitchFamily="49" charset="0"/>
+                <a:ea typeface="Menlo" panose="020B0609030804020204" pitchFamily="49" charset="0"/>
+                <a:cs typeface="Menlo" panose="020B0609030804020204" pitchFamily="49" charset="0"/>
               </a:rPr>
               <a:t>: 'none’</a:t>
             </a:r>
@@ -8774,7 +9263,9 @@
           <a:p>
             <a:r>
               <a:rPr lang="en-GB" sz="1200" dirty="0">
-                <a:latin typeface="Courier" pitchFamily="2" charset="0"/>
+                <a:latin typeface="Menlo" panose="020B0609030804020204" pitchFamily="49" charset="0"/>
+                <a:ea typeface="Menlo" panose="020B0609030804020204" pitchFamily="49" charset="0"/>
+                <a:cs typeface="Menlo" panose="020B0609030804020204" pitchFamily="49" charset="0"/>
               </a:rPr>
               <a:t>version: 1.0.0+1</a:t>
             </a:r>
@@ -8782,12 +9273,16 @@
           <a:p>
             <a:br>
               <a:rPr lang="en-GB" sz="1200" dirty="0">
-                <a:latin typeface="Courier" pitchFamily="2" charset="0"/>
+                <a:latin typeface="Menlo" panose="020B0609030804020204" pitchFamily="49" charset="0"/>
+                <a:ea typeface="Menlo" panose="020B0609030804020204" pitchFamily="49" charset="0"/>
+                <a:cs typeface="Menlo" panose="020B0609030804020204" pitchFamily="49" charset="0"/>
               </a:rPr>
             </a:br>
             <a:r>
               <a:rPr lang="en-GB" sz="1200" dirty="0">
-                <a:latin typeface="Courier" pitchFamily="2" charset="0"/>
+                <a:latin typeface="Menlo" panose="020B0609030804020204" pitchFamily="49" charset="0"/>
+                <a:ea typeface="Menlo" panose="020B0609030804020204" pitchFamily="49" charset="0"/>
+                <a:cs typeface="Menlo" panose="020B0609030804020204" pitchFamily="49" charset="0"/>
               </a:rPr>
               <a:t>environment:</a:t>
             </a:r>
@@ -8795,19 +9290,25 @@
           <a:p>
             <a:r>
               <a:rPr lang="en-GB" sz="1200" dirty="0">
-                <a:latin typeface="Courier" pitchFamily="2" charset="0"/>
+                <a:latin typeface="Menlo" panose="020B0609030804020204" pitchFamily="49" charset="0"/>
+                <a:ea typeface="Menlo" panose="020B0609030804020204" pitchFamily="49" charset="0"/>
+                <a:cs typeface="Menlo" panose="020B0609030804020204" pitchFamily="49" charset="0"/>
               </a:rPr>
               <a:t>  </a:t>
             </a:r>
             <a:r>
               <a:rPr lang="en-GB" sz="1200" dirty="0" err="1">
-                <a:latin typeface="Courier" pitchFamily="2" charset="0"/>
+                <a:latin typeface="Menlo" panose="020B0609030804020204" pitchFamily="49" charset="0"/>
+                <a:ea typeface="Menlo" panose="020B0609030804020204" pitchFamily="49" charset="0"/>
+                <a:cs typeface="Menlo" panose="020B0609030804020204" pitchFamily="49" charset="0"/>
               </a:rPr>
               <a:t>sdk</a:t>
             </a:r>
             <a:r>
               <a:rPr lang="en-GB" sz="1200" dirty="0">
-                <a:latin typeface="Courier" pitchFamily="2" charset="0"/>
+                <a:latin typeface="Menlo" panose="020B0609030804020204" pitchFamily="49" charset="0"/>
+                <a:ea typeface="Menlo" panose="020B0609030804020204" pitchFamily="49" charset="0"/>
+                <a:cs typeface="Menlo" panose="020B0609030804020204" pitchFamily="49" charset="0"/>
               </a:rPr>
               <a:t>: "&gt;=3.2.4 &lt;4.0.0"</a:t>
             </a:r>
@@ -8815,12 +9316,16 @@
           <a:p>
             <a:br>
               <a:rPr lang="en-GB" sz="1200" dirty="0">
-                <a:latin typeface="Courier" pitchFamily="2" charset="0"/>
+                <a:latin typeface="Menlo" panose="020B0609030804020204" pitchFamily="49" charset="0"/>
+                <a:ea typeface="Menlo" panose="020B0609030804020204" pitchFamily="49" charset="0"/>
+                <a:cs typeface="Menlo" panose="020B0609030804020204" pitchFamily="49" charset="0"/>
               </a:rPr>
             </a:br>
             <a:r>
               <a:rPr lang="en-GB" sz="1200" dirty="0">
-                <a:latin typeface="Courier" pitchFamily="2" charset="0"/>
+                <a:latin typeface="Menlo" panose="020B0609030804020204" pitchFamily="49" charset="0"/>
+                <a:ea typeface="Menlo" panose="020B0609030804020204" pitchFamily="49" charset="0"/>
+                <a:cs typeface="Menlo" panose="020B0609030804020204" pitchFamily="49" charset="0"/>
               </a:rPr>
               <a:t>dependencies:</a:t>
             </a:r>
@@ -8828,7 +9333,9 @@
           <a:p>
             <a:r>
               <a:rPr lang="en-GB" sz="1200" dirty="0">
-                <a:latin typeface="Courier" pitchFamily="2" charset="0"/>
+                <a:latin typeface="Menlo" panose="020B0609030804020204" pitchFamily="49" charset="0"/>
+                <a:ea typeface="Menlo" panose="020B0609030804020204" pitchFamily="49" charset="0"/>
+                <a:cs typeface="Menlo" panose="020B0609030804020204" pitchFamily="49" charset="0"/>
               </a:rPr>
               <a:t>  flutter:</a:t>
             </a:r>
@@ -8836,47 +9343,63 @@
           <a:p>
             <a:r>
               <a:rPr lang="en-GB" sz="1200" dirty="0">
-                <a:latin typeface="Courier" pitchFamily="2" charset="0"/>
+                <a:latin typeface="Menlo" panose="020B0609030804020204" pitchFamily="49" charset="0"/>
+                <a:ea typeface="Menlo" panose="020B0609030804020204" pitchFamily="49" charset="0"/>
+                <a:cs typeface="Menlo" panose="020B0609030804020204" pitchFamily="49" charset="0"/>
               </a:rPr>
               <a:t>    </a:t>
             </a:r>
             <a:r>
               <a:rPr lang="en-GB" sz="1200" dirty="0" err="1">
-                <a:latin typeface="Courier" pitchFamily="2" charset="0"/>
+                <a:latin typeface="Menlo" panose="020B0609030804020204" pitchFamily="49" charset="0"/>
+                <a:ea typeface="Menlo" panose="020B0609030804020204" pitchFamily="49" charset="0"/>
+                <a:cs typeface="Menlo" panose="020B0609030804020204" pitchFamily="49" charset="0"/>
               </a:rPr>
               <a:t>sdk</a:t>
             </a:r>
             <a:r>
               <a:rPr lang="en-GB" sz="1200" dirty="0">
-                <a:latin typeface="Courier" pitchFamily="2" charset="0"/>
+                <a:latin typeface="Menlo" panose="020B0609030804020204" pitchFamily="49" charset="0"/>
+                <a:ea typeface="Menlo" panose="020B0609030804020204" pitchFamily="49" charset="0"/>
+                <a:cs typeface="Menlo" panose="020B0609030804020204" pitchFamily="49" charset="0"/>
               </a:rPr>
               <a:t>: flutter</a:t>
             </a:r>
             <a:br>
               <a:rPr lang="en-GB" sz="1200" dirty="0">
-                <a:latin typeface="Courier" pitchFamily="2" charset="0"/>
+                <a:latin typeface="Menlo" panose="020B0609030804020204" pitchFamily="49" charset="0"/>
+                <a:ea typeface="Menlo" panose="020B0609030804020204" pitchFamily="49" charset="0"/>
+                <a:cs typeface="Menlo" panose="020B0609030804020204" pitchFamily="49" charset="0"/>
               </a:rPr>
             </a:br>
             <a:br>
               <a:rPr lang="en-GB" sz="1200" dirty="0">
-                <a:latin typeface="Courier" pitchFamily="2" charset="0"/>
+                <a:latin typeface="Menlo" panose="020B0609030804020204" pitchFamily="49" charset="0"/>
+                <a:ea typeface="Menlo" panose="020B0609030804020204" pitchFamily="49" charset="0"/>
+                <a:cs typeface="Menlo" panose="020B0609030804020204" pitchFamily="49" charset="0"/>
               </a:rPr>
             </a:br>
             <a:r>
               <a:rPr lang="en-GB" sz="1200" dirty="0">
-                <a:latin typeface="Courier" pitchFamily="2" charset="0"/>
+                <a:latin typeface="Menlo" panose="020B0609030804020204" pitchFamily="49" charset="0"/>
+                <a:ea typeface="Menlo" panose="020B0609030804020204" pitchFamily="49" charset="0"/>
+                <a:cs typeface="Menlo" panose="020B0609030804020204" pitchFamily="49" charset="0"/>
               </a:rPr>
               <a:t>  </a:t>
             </a:r>
             <a:r>
               <a:rPr lang="en-GB" sz="1200" dirty="0" err="1">
-                <a:latin typeface="Courier" pitchFamily="2" charset="0"/>
+                <a:latin typeface="Menlo" panose="020B0609030804020204" pitchFamily="49" charset="0"/>
+                <a:ea typeface="Menlo" panose="020B0609030804020204" pitchFamily="49" charset="0"/>
+                <a:cs typeface="Menlo" panose="020B0609030804020204" pitchFamily="49" charset="0"/>
               </a:rPr>
               <a:t>cupertino_icons</a:t>
             </a:r>
             <a:r>
               <a:rPr lang="en-GB" sz="1200" dirty="0">
-                <a:latin typeface="Courier" pitchFamily="2" charset="0"/>
+                <a:latin typeface="Menlo" panose="020B0609030804020204" pitchFamily="49" charset="0"/>
+                <a:ea typeface="Menlo" panose="020B0609030804020204" pitchFamily="49" charset="0"/>
+                <a:cs typeface="Menlo" panose="020B0609030804020204" pitchFamily="49" charset="0"/>
               </a:rPr>
               <a:t>: ^1.0.2</a:t>
             </a:r>
@@ -8884,18 +9407,24 @@
           <a:p>
             <a:br>
               <a:rPr lang="en-GB" sz="1200" dirty="0">
-                <a:latin typeface="Courier" pitchFamily="2" charset="0"/>
+                <a:latin typeface="Menlo" panose="020B0609030804020204" pitchFamily="49" charset="0"/>
+                <a:ea typeface="Menlo" panose="020B0609030804020204" pitchFamily="49" charset="0"/>
+                <a:cs typeface="Menlo" panose="020B0609030804020204" pitchFamily="49" charset="0"/>
               </a:rPr>
             </a:br>
             <a:r>
               <a:rPr lang="en-GB" sz="1200" dirty="0" err="1">
-                <a:latin typeface="Courier" pitchFamily="2" charset="0"/>
+                <a:latin typeface="Menlo" panose="020B0609030804020204" pitchFamily="49" charset="0"/>
+                <a:ea typeface="Menlo" panose="020B0609030804020204" pitchFamily="49" charset="0"/>
+                <a:cs typeface="Menlo" panose="020B0609030804020204" pitchFamily="49" charset="0"/>
               </a:rPr>
               <a:t>dev_dependencies</a:t>
             </a:r>
             <a:r>
               <a:rPr lang="en-GB" sz="1200" dirty="0">
-                <a:latin typeface="Courier" pitchFamily="2" charset="0"/>
+                <a:latin typeface="Menlo" panose="020B0609030804020204" pitchFamily="49" charset="0"/>
+                <a:ea typeface="Menlo" panose="020B0609030804020204" pitchFamily="49" charset="0"/>
+                <a:cs typeface="Menlo" panose="020B0609030804020204" pitchFamily="49" charset="0"/>
               </a:rPr>
               <a:t>:</a:t>
             </a:r>
@@ -8903,19 +9432,25 @@
           <a:p>
             <a:r>
               <a:rPr lang="en-GB" sz="1200" dirty="0">
-                <a:latin typeface="Courier" pitchFamily="2" charset="0"/>
+                <a:latin typeface="Menlo" panose="020B0609030804020204" pitchFamily="49" charset="0"/>
+                <a:ea typeface="Menlo" panose="020B0609030804020204" pitchFamily="49" charset="0"/>
+                <a:cs typeface="Menlo" panose="020B0609030804020204" pitchFamily="49" charset="0"/>
               </a:rPr>
               <a:t>  </a:t>
             </a:r>
             <a:r>
               <a:rPr lang="en-GB" sz="1200" dirty="0" err="1">
-                <a:latin typeface="Courier" pitchFamily="2" charset="0"/>
+                <a:latin typeface="Menlo" panose="020B0609030804020204" pitchFamily="49" charset="0"/>
+                <a:ea typeface="Menlo" panose="020B0609030804020204" pitchFamily="49" charset="0"/>
+                <a:cs typeface="Menlo" panose="020B0609030804020204" pitchFamily="49" charset="0"/>
               </a:rPr>
               <a:t>flutter_test</a:t>
             </a:r>
             <a:r>
               <a:rPr lang="en-GB" sz="1200" dirty="0">
-                <a:latin typeface="Courier" pitchFamily="2" charset="0"/>
+                <a:latin typeface="Menlo" panose="020B0609030804020204" pitchFamily="49" charset="0"/>
+                <a:ea typeface="Menlo" panose="020B0609030804020204" pitchFamily="49" charset="0"/>
+                <a:cs typeface="Menlo" panose="020B0609030804020204" pitchFamily="49" charset="0"/>
               </a:rPr>
               <a:t>:</a:t>
             </a:r>
@@ -8923,19 +9458,25 @@
           <a:p>
             <a:r>
               <a:rPr lang="en-GB" sz="1200" dirty="0">
-                <a:latin typeface="Courier" pitchFamily="2" charset="0"/>
+                <a:latin typeface="Menlo" panose="020B0609030804020204" pitchFamily="49" charset="0"/>
+                <a:ea typeface="Menlo" panose="020B0609030804020204" pitchFamily="49" charset="0"/>
+                <a:cs typeface="Menlo" panose="020B0609030804020204" pitchFamily="49" charset="0"/>
               </a:rPr>
               <a:t>    </a:t>
             </a:r>
             <a:r>
               <a:rPr lang="en-GB" sz="1200" dirty="0" err="1">
-                <a:latin typeface="Courier" pitchFamily="2" charset="0"/>
+                <a:latin typeface="Menlo" panose="020B0609030804020204" pitchFamily="49" charset="0"/>
+                <a:ea typeface="Menlo" panose="020B0609030804020204" pitchFamily="49" charset="0"/>
+                <a:cs typeface="Menlo" panose="020B0609030804020204" pitchFamily="49" charset="0"/>
               </a:rPr>
               <a:t>sdk</a:t>
             </a:r>
             <a:r>
               <a:rPr lang="en-GB" sz="1200" dirty="0">
-                <a:latin typeface="Courier" pitchFamily="2" charset="0"/>
+                <a:latin typeface="Menlo" panose="020B0609030804020204" pitchFamily="49" charset="0"/>
+                <a:ea typeface="Menlo" panose="020B0609030804020204" pitchFamily="49" charset="0"/>
+                <a:cs typeface="Menlo" panose="020B0609030804020204" pitchFamily="49" charset="0"/>
               </a:rPr>
               <a:t>: flutter </a:t>
             </a:r>
@@ -8943,43 +9484,57 @@
           <a:p>
             <a:r>
               <a:rPr lang="en-GB" sz="1200" dirty="0">
-                <a:latin typeface="Courier" pitchFamily="2" charset="0"/>
+                <a:latin typeface="Menlo" panose="020B0609030804020204" pitchFamily="49" charset="0"/>
+                <a:ea typeface="Menlo" panose="020B0609030804020204" pitchFamily="49" charset="0"/>
+                <a:cs typeface="Menlo" panose="020B0609030804020204" pitchFamily="49" charset="0"/>
               </a:rPr>
               <a:t>  </a:t>
             </a:r>
             <a:r>
               <a:rPr lang="en-GB" sz="1200" dirty="0" err="1">
-                <a:latin typeface="Courier" pitchFamily="2" charset="0"/>
+                <a:latin typeface="Menlo" panose="020B0609030804020204" pitchFamily="49" charset="0"/>
+                <a:ea typeface="Menlo" panose="020B0609030804020204" pitchFamily="49" charset="0"/>
+                <a:cs typeface="Menlo" panose="020B0609030804020204" pitchFamily="49" charset="0"/>
               </a:rPr>
               <a:t>flutter_lints</a:t>
             </a:r>
             <a:r>
               <a:rPr lang="en-GB" sz="1200" dirty="0">
-                <a:latin typeface="Courier" pitchFamily="2" charset="0"/>
+                <a:latin typeface="Menlo" panose="020B0609030804020204" pitchFamily="49" charset="0"/>
+                <a:ea typeface="Menlo" panose="020B0609030804020204" pitchFamily="49" charset="0"/>
+                <a:cs typeface="Menlo" panose="020B0609030804020204" pitchFamily="49" charset="0"/>
               </a:rPr>
               <a:t>: ^2.0.0</a:t>
             </a:r>
           </a:p>
           <a:p>
             <a:endParaRPr lang="en-GB" sz="1200" dirty="0">
-              <a:latin typeface="Courier" pitchFamily="2" charset="0"/>
+              <a:latin typeface="Menlo" panose="020B0609030804020204" pitchFamily="49" charset="0"/>
+              <a:ea typeface="Menlo" panose="020B0609030804020204" pitchFamily="49" charset="0"/>
+              <a:cs typeface="Menlo" panose="020B0609030804020204" pitchFamily="49" charset="0"/>
             </a:endParaRPr>
           </a:p>
           <a:p>
             <a:r>
               <a:rPr lang="en-GB" sz="1200" dirty="0">
-                <a:latin typeface="Courier" pitchFamily="2" charset="0"/>
+                <a:latin typeface="Menlo" panose="020B0609030804020204" pitchFamily="49" charset="0"/>
+                <a:ea typeface="Menlo" panose="020B0609030804020204" pitchFamily="49" charset="0"/>
+                <a:cs typeface="Menlo" panose="020B0609030804020204" pitchFamily="49" charset="0"/>
               </a:rPr>
               <a:t>flutter:</a:t>
             </a:r>
             <a:br>
               <a:rPr lang="en-GB" sz="1200" dirty="0">
-                <a:latin typeface="Courier" pitchFamily="2" charset="0"/>
+                <a:latin typeface="Menlo" panose="020B0609030804020204" pitchFamily="49" charset="0"/>
+                <a:ea typeface="Menlo" panose="020B0609030804020204" pitchFamily="49" charset="0"/>
+                <a:cs typeface="Menlo" panose="020B0609030804020204" pitchFamily="49" charset="0"/>
               </a:rPr>
             </a:br>
             <a:r>
               <a:rPr lang="en-GB" sz="1200" dirty="0">
-                <a:latin typeface="Courier" pitchFamily="2" charset="0"/>
+                <a:latin typeface="Menlo" panose="020B0609030804020204" pitchFamily="49" charset="0"/>
+                <a:ea typeface="Menlo" panose="020B0609030804020204" pitchFamily="49" charset="0"/>
+                <a:cs typeface="Menlo" panose="020B0609030804020204" pitchFamily="49" charset="0"/>
               </a:rPr>
               <a:t>  uses-material-design: true</a:t>
             </a:r>
@@ -11405,20 +11960,26 @@
           <a:p>
             <a:r>
               <a:rPr lang="en-GB" dirty="0">
-                <a:latin typeface="Courier" pitchFamily="2" charset="0"/>
+                <a:latin typeface="Menlo" panose="020B0609030804020204" pitchFamily="49" charset="0"/>
+                <a:ea typeface="Menlo" panose="020B0609030804020204" pitchFamily="49" charset="0"/>
+                <a:cs typeface="Menlo" panose="020B0609030804020204" pitchFamily="49" charset="0"/>
               </a:rPr>
               <a:t>...</a:t>
             </a:r>
           </a:p>
           <a:p>
             <a:endParaRPr lang="en-GB" dirty="0">
-              <a:latin typeface="Courier" pitchFamily="2" charset="0"/>
+              <a:latin typeface="Menlo" panose="020B0609030804020204" pitchFamily="49" charset="0"/>
+              <a:ea typeface="Menlo" panose="020B0609030804020204" pitchFamily="49" charset="0"/>
+              <a:cs typeface="Menlo" panose="020B0609030804020204" pitchFamily="49" charset="0"/>
             </a:endParaRPr>
           </a:p>
           <a:p>
             <a:r>
               <a:rPr lang="en-GB" dirty="0">
-                <a:latin typeface="Courier" pitchFamily="2" charset="0"/>
+                <a:latin typeface="Menlo" panose="020B0609030804020204" pitchFamily="49" charset="0"/>
+                <a:ea typeface="Menlo" panose="020B0609030804020204" pitchFamily="49" charset="0"/>
+                <a:cs typeface="Menlo" panose="020B0609030804020204" pitchFamily="49" charset="0"/>
               </a:rPr>
               <a:t>dependencies:</a:t>
             </a:r>
@@ -11426,7 +11987,9 @@
           <a:p>
             <a:r>
               <a:rPr lang="en-GB" dirty="0">
-                <a:latin typeface="Courier" pitchFamily="2" charset="0"/>
+                <a:latin typeface="Menlo" panose="020B0609030804020204" pitchFamily="49" charset="0"/>
+                <a:ea typeface="Menlo" panose="020B0609030804020204" pitchFamily="49" charset="0"/>
+                <a:cs typeface="Menlo" panose="020B0609030804020204" pitchFamily="49" charset="0"/>
               </a:rPr>
               <a:t>  flutter:</a:t>
             </a:r>
@@ -11434,19 +11997,25 @@
           <a:p>
             <a:r>
               <a:rPr lang="en-GB" dirty="0">
-                <a:latin typeface="Courier" pitchFamily="2" charset="0"/>
+                <a:latin typeface="Menlo" panose="020B0609030804020204" pitchFamily="49" charset="0"/>
+                <a:ea typeface="Menlo" panose="020B0609030804020204" pitchFamily="49" charset="0"/>
+                <a:cs typeface="Menlo" panose="020B0609030804020204" pitchFamily="49" charset="0"/>
               </a:rPr>
               <a:t>    </a:t>
             </a:r>
             <a:r>
               <a:rPr lang="en-GB" dirty="0" err="1">
-                <a:latin typeface="Courier" pitchFamily="2" charset="0"/>
+                <a:latin typeface="Menlo" panose="020B0609030804020204" pitchFamily="49" charset="0"/>
+                <a:ea typeface="Menlo" panose="020B0609030804020204" pitchFamily="49" charset="0"/>
+                <a:cs typeface="Menlo" panose="020B0609030804020204" pitchFamily="49" charset="0"/>
               </a:rPr>
               <a:t>sdk</a:t>
             </a:r>
             <a:r>
               <a:rPr lang="en-GB" dirty="0">
-                <a:latin typeface="Courier" pitchFamily="2" charset="0"/>
+                <a:latin typeface="Menlo" panose="020B0609030804020204" pitchFamily="49" charset="0"/>
+                <a:ea typeface="Menlo" panose="020B0609030804020204" pitchFamily="49" charset="0"/>
+                <a:cs typeface="Menlo" panose="020B0609030804020204" pitchFamily="49" charset="0"/>
               </a:rPr>
               <a:t>: flutter</a:t>
             </a:r>
@@ -11454,24 +12023,32 @@
           <a:p>
             <a:br>
               <a:rPr lang="en-GB" dirty="0">
-                <a:latin typeface="Courier" pitchFamily="2" charset="0"/>
+                <a:latin typeface="Menlo" panose="020B0609030804020204" pitchFamily="49" charset="0"/>
+                <a:ea typeface="Menlo" panose="020B0609030804020204" pitchFamily="49" charset="0"/>
+                <a:cs typeface="Menlo" panose="020B0609030804020204" pitchFamily="49" charset="0"/>
               </a:rPr>
             </a:br>
             <a:r>
               <a:rPr lang="en-GB" dirty="0">
-                <a:latin typeface="Courier" pitchFamily="2" charset="0"/>
+                <a:latin typeface="Menlo" panose="020B0609030804020204" pitchFamily="49" charset="0"/>
+                <a:ea typeface="Menlo" panose="020B0609030804020204" pitchFamily="49" charset="0"/>
+                <a:cs typeface="Menlo" panose="020B0609030804020204" pitchFamily="49" charset="0"/>
               </a:rPr>
               <a:t>  </a:t>
             </a:r>
             <a:r>
               <a:rPr lang="en-GB" dirty="0" err="1">
-                <a:latin typeface="Courier" pitchFamily="2" charset="0"/>
+                <a:latin typeface="Menlo" panose="020B0609030804020204" pitchFamily="49" charset="0"/>
+                <a:ea typeface="Menlo" panose="020B0609030804020204" pitchFamily="49" charset="0"/>
+                <a:cs typeface="Menlo" panose="020B0609030804020204" pitchFamily="49" charset="0"/>
               </a:rPr>
               <a:t>cupertino_icons</a:t>
             </a:r>
             <a:r>
               <a:rPr lang="en-GB" dirty="0">
-                <a:latin typeface="Courier" pitchFamily="2" charset="0"/>
+                <a:latin typeface="Menlo" panose="020B0609030804020204" pitchFamily="49" charset="0"/>
+                <a:ea typeface="Menlo" panose="020B0609030804020204" pitchFamily="49" charset="0"/>
+                <a:cs typeface="Menlo" panose="020B0609030804020204" pitchFamily="49" charset="0"/>
               </a:rPr>
               <a:t>: ^1.0.2</a:t>
             </a:r>
@@ -11479,43 +12056,57 @@
           <a:p>
             <a:br>
               <a:rPr lang="en-GB" b="1" dirty="0">
-                <a:latin typeface="Courier" pitchFamily="2" charset="0"/>
+                <a:latin typeface="Menlo" panose="020B0609030804020204" pitchFamily="49" charset="0"/>
+                <a:ea typeface="Menlo" panose="020B0609030804020204" pitchFamily="49" charset="0"/>
+                <a:cs typeface="Menlo" panose="020B0609030804020204" pitchFamily="49" charset="0"/>
               </a:rPr>
             </a:br>
             <a:r>
               <a:rPr lang="en-GB" b="1" dirty="0">
-                <a:latin typeface="Courier" pitchFamily="2" charset="0"/>
+                <a:latin typeface="Menlo" panose="020B0609030804020204" pitchFamily="49" charset="0"/>
+                <a:ea typeface="Menlo" panose="020B0609030804020204" pitchFamily="49" charset="0"/>
+                <a:cs typeface="Menlo" panose="020B0609030804020204" pitchFamily="49" charset="0"/>
               </a:rPr>
               <a:t>  </a:t>
             </a:r>
             <a:r>
               <a:rPr lang="en-GB" b="1" dirty="0" err="1">
-                <a:latin typeface="Courier" pitchFamily="2" charset="0"/>
+                <a:latin typeface="Menlo" panose="020B0609030804020204" pitchFamily="49" charset="0"/>
+                <a:ea typeface="Menlo" panose="020B0609030804020204" pitchFamily="49" charset="0"/>
+                <a:cs typeface="Menlo" panose="020B0609030804020204" pitchFamily="49" charset="0"/>
               </a:rPr>
               <a:t>english_words</a:t>
             </a:r>
             <a:r>
               <a:rPr lang="en-GB" b="1" dirty="0">
-                <a:latin typeface="Courier" pitchFamily="2" charset="0"/>
+                <a:latin typeface="Menlo" panose="020B0609030804020204" pitchFamily="49" charset="0"/>
+                <a:ea typeface="Menlo" panose="020B0609030804020204" pitchFamily="49" charset="0"/>
+                <a:cs typeface="Menlo" panose="020B0609030804020204" pitchFamily="49" charset="0"/>
               </a:rPr>
               <a:t>: ^4.0.0</a:t>
             </a:r>
           </a:p>
           <a:p>
             <a:endParaRPr lang="en-GB" b="1" dirty="0">
-              <a:latin typeface="Courier" pitchFamily="2" charset="0"/>
+              <a:latin typeface="Menlo" panose="020B0609030804020204" pitchFamily="49" charset="0"/>
+              <a:ea typeface="Menlo" panose="020B0609030804020204" pitchFamily="49" charset="0"/>
+              <a:cs typeface="Menlo" panose="020B0609030804020204" pitchFamily="49" charset="0"/>
             </a:endParaRPr>
           </a:p>
           <a:p>
             <a:r>
               <a:rPr lang="en-GB" dirty="0">
-                <a:latin typeface="Courier" pitchFamily="2" charset="0"/>
+                <a:latin typeface="Menlo" panose="020B0609030804020204" pitchFamily="49" charset="0"/>
+                <a:ea typeface="Menlo" panose="020B0609030804020204" pitchFamily="49" charset="0"/>
+                <a:cs typeface="Menlo" panose="020B0609030804020204" pitchFamily="49" charset="0"/>
               </a:rPr>
               <a:t>...</a:t>
             </a:r>
             <a:r>
               <a:rPr lang="en-GB" b="1" dirty="0">
-                <a:latin typeface="Courier" pitchFamily="2" charset="0"/>
+                <a:latin typeface="Menlo" panose="020B0609030804020204" pitchFamily="49" charset="0"/>
+                <a:ea typeface="Menlo" panose="020B0609030804020204" pitchFamily="49" charset="0"/>
+                <a:cs typeface="Menlo" panose="020B0609030804020204" pitchFamily="49" charset="0"/>
               </a:rPr>
               <a:t> </a:t>
             </a:r>
@@ -11897,19 +12488,25 @@
             </a:pPr>
             <a:r>
               <a:rPr lang="en-US" b="1" dirty="0">
-                <a:latin typeface="Courier" pitchFamily="2" charset="0"/>
+                <a:latin typeface="Menlo" panose="020B0609030804020204" pitchFamily="49" charset="0"/>
+                <a:ea typeface="Menlo" panose="020B0609030804020204" pitchFamily="49" charset="0"/>
+                <a:cs typeface="Menlo" panose="020B0609030804020204" pitchFamily="49" charset="0"/>
               </a:rPr>
               <a:t>final word = </a:t>
             </a:r>
             <a:r>
               <a:rPr lang="en-US" b="1" dirty="0" err="1">
-                <a:latin typeface="Courier" pitchFamily="2" charset="0"/>
+                <a:latin typeface="Menlo" panose="020B0609030804020204" pitchFamily="49" charset="0"/>
+                <a:ea typeface="Menlo" panose="020B0609030804020204" pitchFamily="49" charset="0"/>
+                <a:cs typeface="Menlo" panose="020B0609030804020204" pitchFamily="49" charset="0"/>
               </a:rPr>
               <a:t>WordPair.random</a:t>
             </a:r>
             <a:r>
               <a:rPr lang="en-US" b="1" dirty="0">
-                <a:latin typeface="Courier" pitchFamily="2" charset="0"/>
+                <a:latin typeface="Menlo" panose="020B0609030804020204" pitchFamily="49" charset="0"/>
+                <a:ea typeface="Menlo" panose="020B0609030804020204" pitchFamily="49" charset="0"/>
+                <a:cs typeface="Menlo" panose="020B0609030804020204" pitchFamily="49" charset="0"/>
               </a:rPr>
               <a:t>().first;</a:t>
             </a:r>
@@ -12086,19 +12683,25 @@
             </a:pPr>
             <a:r>
               <a:rPr lang="en-US" b="1" dirty="0">
-                <a:latin typeface="Courier" pitchFamily="2" charset="0"/>
+                <a:latin typeface="Menlo" panose="020B0609030804020204" pitchFamily="49" charset="0"/>
+                <a:ea typeface="Menlo" panose="020B0609030804020204" pitchFamily="49" charset="0"/>
+                <a:cs typeface="Menlo" panose="020B0609030804020204" pitchFamily="49" charset="0"/>
               </a:rPr>
               <a:t>final word = </a:t>
             </a:r>
             <a:r>
               <a:rPr lang="en-US" b="1" dirty="0" err="1">
-                <a:latin typeface="Courier" pitchFamily="2" charset="0"/>
+                <a:latin typeface="Menlo" panose="020B0609030804020204" pitchFamily="49" charset="0"/>
+                <a:ea typeface="Menlo" panose="020B0609030804020204" pitchFamily="49" charset="0"/>
+                <a:cs typeface="Menlo" panose="020B0609030804020204" pitchFamily="49" charset="0"/>
               </a:rPr>
               <a:t>WordPair.random</a:t>
             </a:r>
             <a:r>
               <a:rPr lang="en-US" b="1" dirty="0">
-                <a:latin typeface="Courier" pitchFamily="2" charset="0"/>
+                <a:latin typeface="Menlo" panose="020B0609030804020204" pitchFamily="49" charset="0"/>
+                <a:ea typeface="Menlo" panose="020B0609030804020204" pitchFamily="49" charset="0"/>
+                <a:cs typeface="Menlo" panose="020B0609030804020204" pitchFamily="49" charset="0"/>
               </a:rPr>
               <a:t>().first;</a:t>
             </a:r>
@@ -12109,7 +12712,9 @@
             </a:pPr>
             <a:r>
               <a:rPr lang="en-US" b="1" dirty="0">
-                <a:latin typeface="Courier" pitchFamily="2" charset="0"/>
+                <a:latin typeface="Menlo" panose="020B0609030804020204" pitchFamily="49" charset="0"/>
+                <a:ea typeface="Menlo" panose="020B0609030804020204" pitchFamily="49" charset="0"/>
+                <a:cs typeface="Menlo" panose="020B0609030804020204" pitchFamily="49" charset="0"/>
               </a:rPr>
               <a:t>print(word);</a:t>
             </a:r>
@@ -13299,7 +13904,9 @@
             </a:pPr>
             <a:r>
               <a:rPr lang="en-US" dirty="0">
-                <a:latin typeface="Courier" pitchFamily="2" charset="0"/>
+                <a:latin typeface="Menlo" panose="020B0609030804020204" pitchFamily="49" charset="0"/>
+                <a:ea typeface="Menlo" panose="020B0609030804020204" pitchFamily="49" charset="0"/>
+                <a:cs typeface="Menlo" panose="020B0609030804020204" pitchFamily="49" charset="0"/>
               </a:rPr>
               <a:t>‘Hello, Flutter!’</a:t>
             </a:r>
@@ -13309,7 +13916,9 @@
             </a:r>
             <a:r>
               <a:rPr lang="en-US" dirty="0">
-                <a:latin typeface="Courier" pitchFamily="2" charset="0"/>
+                <a:latin typeface="Menlo" panose="020B0609030804020204" pitchFamily="49" charset="0"/>
+                <a:ea typeface="Menlo" panose="020B0609030804020204" pitchFamily="49" charset="0"/>
+                <a:cs typeface="Menlo" panose="020B0609030804020204" pitchFamily="49" charset="0"/>
               </a:rPr>
               <a:t>’Hello, $word!’</a:t>
             </a:r>
@@ -15603,42 +16212,56 @@
           <a:p>
             <a:r>
               <a:rPr lang="en-GB" dirty="0">
-                <a:latin typeface="Courier" pitchFamily="2" charset="0"/>
+                <a:latin typeface="Menlo" panose="020B0609030804020204" pitchFamily="49" charset="0"/>
+                <a:ea typeface="Menlo" panose="020B0609030804020204" pitchFamily="49" charset="0"/>
+                <a:cs typeface="Menlo" panose="020B0609030804020204" pitchFamily="49" charset="0"/>
               </a:rPr>
               <a:t>import '</a:t>
             </a:r>
             <a:r>
               <a:rPr lang="en-GB" dirty="0" err="1">
-                <a:latin typeface="Courier" pitchFamily="2" charset="0"/>
+                <a:latin typeface="Menlo" panose="020B0609030804020204" pitchFamily="49" charset="0"/>
+                <a:ea typeface="Menlo" panose="020B0609030804020204" pitchFamily="49" charset="0"/>
+                <a:cs typeface="Menlo" panose="020B0609030804020204" pitchFamily="49" charset="0"/>
               </a:rPr>
               <a:t>package:flutter</a:t>
             </a:r>
             <a:r>
               <a:rPr lang="en-GB" dirty="0">
-                <a:latin typeface="Courier" pitchFamily="2" charset="0"/>
+                <a:latin typeface="Menlo" panose="020B0609030804020204" pitchFamily="49" charset="0"/>
+                <a:ea typeface="Menlo" panose="020B0609030804020204" pitchFamily="49" charset="0"/>
+                <a:cs typeface="Menlo" panose="020B0609030804020204" pitchFamily="49" charset="0"/>
               </a:rPr>
               <a:t>/</a:t>
             </a:r>
             <a:r>
               <a:rPr lang="en-GB" dirty="0" err="1">
-                <a:latin typeface="Courier" pitchFamily="2" charset="0"/>
+                <a:latin typeface="Menlo" panose="020B0609030804020204" pitchFamily="49" charset="0"/>
+                <a:ea typeface="Menlo" panose="020B0609030804020204" pitchFamily="49" charset="0"/>
+                <a:cs typeface="Menlo" panose="020B0609030804020204" pitchFamily="49" charset="0"/>
               </a:rPr>
               <a:t>material.dart</a:t>
             </a:r>
             <a:r>
               <a:rPr lang="en-GB" dirty="0">
-                <a:latin typeface="Courier" pitchFamily="2" charset="0"/>
+                <a:latin typeface="Menlo" panose="020B0609030804020204" pitchFamily="49" charset="0"/>
+                <a:ea typeface="Menlo" panose="020B0609030804020204" pitchFamily="49" charset="0"/>
+                <a:cs typeface="Menlo" panose="020B0609030804020204" pitchFamily="49" charset="0"/>
               </a:rPr>
               <a:t>';</a:t>
             </a:r>
             <a:br>
               <a:rPr lang="en-GB" dirty="0">
-                <a:latin typeface="Courier" pitchFamily="2" charset="0"/>
+                <a:latin typeface="Menlo" panose="020B0609030804020204" pitchFamily="49" charset="0"/>
+                <a:ea typeface="Menlo" panose="020B0609030804020204" pitchFamily="49" charset="0"/>
+                <a:cs typeface="Menlo" panose="020B0609030804020204" pitchFamily="49" charset="0"/>
               </a:rPr>
             </a:br>
             <a:r>
               <a:rPr lang="en-GB" dirty="0">
-                <a:latin typeface="Courier" pitchFamily="2" charset="0"/>
+                <a:latin typeface="Menlo" panose="020B0609030804020204" pitchFamily="49" charset="0"/>
+                <a:ea typeface="Menlo" panose="020B0609030804020204" pitchFamily="49" charset="0"/>
+                <a:cs typeface="Menlo" panose="020B0609030804020204" pitchFamily="49" charset="0"/>
               </a:rPr>
               <a:t>void main() {</a:t>
             </a:r>
@@ -15646,31 +16269,41 @@
           <a:p>
             <a:r>
               <a:rPr lang="en-GB" dirty="0">
-                <a:latin typeface="Courier" pitchFamily="2" charset="0"/>
+                <a:latin typeface="Menlo" panose="020B0609030804020204" pitchFamily="49" charset="0"/>
+                <a:ea typeface="Menlo" panose="020B0609030804020204" pitchFamily="49" charset="0"/>
+                <a:cs typeface="Menlo" panose="020B0609030804020204" pitchFamily="49" charset="0"/>
               </a:rPr>
               <a:t>  </a:t>
             </a:r>
             <a:r>
               <a:rPr lang="en-GB" dirty="0" err="1">
-                <a:latin typeface="Courier" pitchFamily="2" charset="0"/>
+                <a:latin typeface="Menlo" panose="020B0609030804020204" pitchFamily="49" charset="0"/>
+                <a:ea typeface="Menlo" panose="020B0609030804020204" pitchFamily="49" charset="0"/>
+                <a:cs typeface="Menlo" panose="020B0609030804020204" pitchFamily="49" charset="0"/>
               </a:rPr>
               <a:t>runApp</a:t>
             </a:r>
             <a:r>
               <a:rPr lang="en-GB" dirty="0">
-                <a:latin typeface="Courier" pitchFamily="2" charset="0"/>
+                <a:latin typeface="Menlo" panose="020B0609030804020204" pitchFamily="49" charset="0"/>
+                <a:ea typeface="Menlo" panose="020B0609030804020204" pitchFamily="49" charset="0"/>
+                <a:cs typeface="Menlo" panose="020B0609030804020204" pitchFamily="49" charset="0"/>
               </a:rPr>
               <a:t>(</a:t>
             </a:r>
             <a:r>
               <a:rPr lang="en-GB" dirty="0" err="1">
-                <a:latin typeface="Courier" pitchFamily="2" charset="0"/>
+                <a:latin typeface="Menlo" panose="020B0609030804020204" pitchFamily="49" charset="0"/>
+                <a:ea typeface="Menlo" panose="020B0609030804020204" pitchFamily="49" charset="0"/>
+                <a:cs typeface="Menlo" panose="020B0609030804020204" pitchFamily="49" charset="0"/>
               </a:rPr>
               <a:t>MyApp</a:t>
             </a:r>
             <a:r>
               <a:rPr lang="en-GB" dirty="0">
-                <a:latin typeface="Courier" pitchFamily="2" charset="0"/>
+                <a:latin typeface="Menlo" panose="020B0609030804020204" pitchFamily="49" charset="0"/>
+                <a:ea typeface="Menlo" panose="020B0609030804020204" pitchFamily="49" charset="0"/>
+                <a:cs typeface="Menlo" panose="020B0609030804020204" pitchFamily="49" charset="0"/>
               </a:rPr>
               <a:t>());</a:t>
             </a:r>
@@ -15678,42 +16311,56 @@
           <a:p>
             <a:r>
               <a:rPr lang="en-GB" dirty="0">
-                <a:latin typeface="Courier" pitchFamily="2" charset="0"/>
+                <a:latin typeface="Menlo" panose="020B0609030804020204" pitchFamily="49" charset="0"/>
+                <a:ea typeface="Menlo" panose="020B0609030804020204" pitchFamily="49" charset="0"/>
+                <a:cs typeface="Menlo" panose="020B0609030804020204" pitchFamily="49" charset="0"/>
               </a:rPr>
               <a:t>}//main</a:t>
             </a:r>
             <a:br>
               <a:rPr lang="en-GB" dirty="0">
-                <a:latin typeface="Courier" pitchFamily="2" charset="0"/>
+                <a:latin typeface="Menlo" panose="020B0609030804020204" pitchFamily="49" charset="0"/>
+                <a:ea typeface="Menlo" panose="020B0609030804020204" pitchFamily="49" charset="0"/>
+                <a:cs typeface="Menlo" panose="020B0609030804020204" pitchFamily="49" charset="0"/>
               </a:rPr>
             </a:br>
             <a:r>
               <a:rPr lang="en-GB" dirty="0">
-                <a:latin typeface="Courier" pitchFamily="2" charset="0"/>
+                <a:latin typeface="Menlo" panose="020B0609030804020204" pitchFamily="49" charset="0"/>
+                <a:ea typeface="Menlo" panose="020B0609030804020204" pitchFamily="49" charset="0"/>
+                <a:cs typeface="Menlo" panose="020B0609030804020204" pitchFamily="49" charset="0"/>
               </a:rPr>
               <a:t>class </a:t>
             </a:r>
             <a:r>
               <a:rPr lang="en-GB" dirty="0" err="1">
-                <a:latin typeface="Courier" pitchFamily="2" charset="0"/>
+                <a:latin typeface="Menlo" panose="020B0609030804020204" pitchFamily="49" charset="0"/>
+                <a:ea typeface="Menlo" panose="020B0609030804020204" pitchFamily="49" charset="0"/>
+                <a:cs typeface="Menlo" panose="020B0609030804020204" pitchFamily="49" charset="0"/>
               </a:rPr>
               <a:t>MyApp</a:t>
             </a:r>
             <a:r>
               <a:rPr lang="en-GB" dirty="0">
-                <a:latin typeface="Courier" pitchFamily="2" charset="0"/>
+                <a:latin typeface="Menlo" panose="020B0609030804020204" pitchFamily="49" charset="0"/>
+                <a:ea typeface="Menlo" panose="020B0609030804020204" pitchFamily="49" charset="0"/>
+                <a:cs typeface="Menlo" panose="020B0609030804020204" pitchFamily="49" charset="0"/>
               </a:rPr>
               <a:t> extends </a:t>
             </a:r>
             <a:r>
               <a:rPr lang="en-GB" dirty="0" err="1">
-                <a:latin typeface="Courier" pitchFamily="2" charset="0"/>
+                <a:latin typeface="Menlo" panose="020B0609030804020204" pitchFamily="49" charset="0"/>
+                <a:ea typeface="Menlo" panose="020B0609030804020204" pitchFamily="49" charset="0"/>
+                <a:cs typeface="Menlo" panose="020B0609030804020204" pitchFamily="49" charset="0"/>
               </a:rPr>
               <a:t>StatelessWidget</a:t>
             </a:r>
             <a:r>
               <a:rPr lang="en-GB" dirty="0">
-                <a:latin typeface="Courier" pitchFamily="2" charset="0"/>
+                <a:latin typeface="Menlo" panose="020B0609030804020204" pitchFamily="49" charset="0"/>
+                <a:ea typeface="Menlo" panose="020B0609030804020204" pitchFamily="49" charset="0"/>
+                <a:cs typeface="Menlo" panose="020B0609030804020204" pitchFamily="49" charset="0"/>
               </a:rPr>
               <a:t> {</a:t>
             </a:r>
@@ -15721,19 +16368,25 @@
           <a:p>
             <a:r>
               <a:rPr lang="en-GB" dirty="0">
-                <a:latin typeface="Courier" pitchFamily="2" charset="0"/>
+                <a:latin typeface="Menlo" panose="020B0609030804020204" pitchFamily="49" charset="0"/>
+                <a:ea typeface="Menlo" panose="020B0609030804020204" pitchFamily="49" charset="0"/>
+                <a:cs typeface="Menlo" panose="020B0609030804020204" pitchFamily="49" charset="0"/>
               </a:rPr>
               <a:t>  </a:t>
             </a:r>
             <a:r>
               <a:rPr lang="en-GB" dirty="0" err="1">
-                <a:latin typeface="Courier" pitchFamily="2" charset="0"/>
+                <a:latin typeface="Menlo" panose="020B0609030804020204" pitchFamily="49" charset="0"/>
+                <a:ea typeface="Menlo" panose="020B0609030804020204" pitchFamily="49" charset="0"/>
+                <a:cs typeface="Menlo" panose="020B0609030804020204" pitchFamily="49" charset="0"/>
               </a:rPr>
               <a:t>MyApp</a:t>
             </a:r>
             <a:r>
               <a:rPr lang="en-GB" dirty="0">
-                <a:latin typeface="Courier" pitchFamily="2" charset="0"/>
+                <a:latin typeface="Menlo" panose="020B0609030804020204" pitchFamily="49" charset="0"/>
+                <a:ea typeface="Menlo" panose="020B0609030804020204" pitchFamily="49" charset="0"/>
+                <a:cs typeface="Menlo" panose="020B0609030804020204" pitchFamily="49" charset="0"/>
               </a:rPr>
               <a:t>({Key? key}) : super(key: key);</a:t>
             </a:r>
@@ -15741,12 +16394,16 @@
           <a:p>
             <a:br>
               <a:rPr lang="en-GB" dirty="0">
-                <a:latin typeface="Courier" pitchFamily="2" charset="0"/>
+                <a:latin typeface="Menlo" panose="020B0609030804020204" pitchFamily="49" charset="0"/>
+                <a:ea typeface="Menlo" panose="020B0609030804020204" pitchFamily="49" charset="0"/>
+                <a:cs typeface="Menlo" panose="020B0609030804020204" pitchFamily="49" charset="0"/>
               </a:rPr>
             </a:br>
             <a:r>
               <a:rPr lang="en-GB" dirty="0">
-                <a:latin typeface="Courier" pitchFamily="2" charset="0"/>
+                <a:latin typeface="Menlo" panose="020B0609030804020204" pitchFamily="49" charset="0"/>
+                <a:ea typeface="Menlo" panose="020B0609030804020204" pitchFamily="49" charset="0"/>
+                <a:cs typeface="Menlo" panose="020B0609030804020204" pitchFamily="49" charset="0"/>
               </a:rPr>
               <a:t>  @override</a:t>
             </a:r>
@@ -15754,19 +16411,25 @@
           <a:p>
             <a:r>
               <a:rPr lang="en-GB" dirty="0">
-                <a:latin typeface="Courier" pitchFamily="2" charset="0"/>
+                <a:latin typeface="Menlo" panose="020B0609030804020204" pitchFamily="49" charset="0"/>
+                <a:ea typeface="Menlo" panose="020B0609030804020204" pitchFamily="49" charset="0"/>
+                <a:cs typeface="Menlo" panose="020B0609030804020204" pitchFamily="49" charset="0"/>
               </a:rPr>
               <a:t>  Widget build(</a:t>
             </a:r>
             <a:r>
               <a:rPr lang="en-GB" dirty="0" err="1">
-                <a:latin typeface="Courier" pitchFamily="2" charset="0"/>
+                <a:latin typeface="Menlo" panose="020B0609030804020204" pitchFamily="49" charset="0"/>
+                <a:ea typeface="Menlo" panose="020B0609030804020204" pitchFamily="49" charset="0"/>
+                <a:cs typeface="Menlo" panose="020B0609030804020204" pitchFamily="49" charset="0"/>
               </a:rPr>
               <a:t>BuildContext</a:t>
             </a:r>
             <a:r>
               <a:rPr lang="en-GB" dirty="0">
-                <a:latin typeface="Courier" pitchFamily="2" charset="0"/>
+                <a:latin typeface="Menlo" panose="020B0609030804020204" pitchFamily="49" charset="0"/>
+                <a:ea typeface="Menlo" panose="020B0609030804020204" pitchFamily="49" charset="0"/>
+                <a:cs typeface="Menlo" panose="020B0609030804020204" pitchFamily="49" charset="0"/>
               </a:rPr>
               <a:t> context) {</a:t>
             </a:r>
@@ -15774,19 +16437,25 @@
           <a:p>
             <a:r>
               <a:rPr lang="en-GB" dirty="0">
-                <a:latin typeface="Courier" pitchFamily="2" charset="0"/>
+                <a:latin typeface="Menlo" panose="020B0609030804020204" pitchFamily="49" charset="0"/>
+                <a:ea typeface="Menlo" panose="020B0609030804020204" pitchFamily="49" charset="0"/>
+                <a:cs typeface="Menlo" panose="020B0609030804020204" pitchFamily="49" charset="0"/>
               </a:rPr>
               <a:t>    return </a:t>
             </a:r>
             <a:r>
               <a:rPr lang="en-GB" dirty="0" err="1">
-                <a:latin typeface="Courier" pitchFamily="2" charset="0"/>
+                <a:latin typeface="Menlo" panose="020B0609030804020204" pitchFamily="49" charset="0"/>
+                <a:ea typeface="Menlo" panose="020B0609030804020204" pitchFamily="49" charset="0"/>
+                <a:cs typeface="Menlo" panose="020B0609030804020204" pitchFamily="49" charset="0"/>
               </a:rPr>
               <a:t>MaterialApp</a:t>
             </a:r>
             <a:r>
               <a:rPr lang="en-GB" dirty="0">
-                <a:latin typeface="Courier" pitchFamily="2" charset="0"/>
+                <a:latin typeface="Menlo" panose="020B0609030804020204" pitchFamily="49" charset="0"/>
+                <a:ea typeface="Menlo" panose="020B0609030804020204" pitchFamily="49" charset="0"/>
+                <a:cs typeface="Menlo" panose="020B0609030804020204" pitchFamily="49" charset="0"/>
               </a:rPr>
               <a:t>(</a:t>
             </a:r>
@@ -15794,7 +16463,9 @@
           <a:p>
             <a:r>
               <a:rPr lang="en-GB" dirty="0">
-                <a:latin typeface="Courier" pitchFamily="2" charset="0"/>
+                <a:latin typeface="Menlo" panose="020B0609030804020204" pitchFamily="49" charset="0"/>
+                <a:ea typeface="Menlo" panose="020B0609030804020204" pitchFamily="49" charset="0"/>
+                <a:cs typeface="Menlo" panose="020B0609030804020204" pitchFamily="49" charset="0"/>
               </a:rPr>
               <a:t>      title: 'Welcome to Flutter’,</a:t>
             </a:r>
@@ -15802,7 +16473,9 @@
           <a:p>
             <a:r>
               <a:rPr lang="en-GB" dirty="0">
-                <a:latin typeface="Courier" pitchFamily="2" charset="0"/>
+                <a:latin typeface="Menlo" panose="020B0609030804020204" pitchFamily="49" charset="0"/>
+                <a:ea typeface="Menlo" panose="020B0609030804020204" pitchFamily="49" charset="0"/>
+                <a:cs typeface="Menlo" panose="020B0609030804020204" pitchFamily="49" charset="0"/>
               </a:rPr>
               <a:t>      home: Scaffold(</a:t>
             </a:r>
@@ -15810,31 +16483,41 @@
           <a:p>
             <a:r>
               <a:rPr lang="en-GB" dirty="0">
-                <a:latin typeface="Courier" pitchFamily="2" charset="0"/>
+                <a:latin typeface="Menlo" panose="020B0609030804020204" pitchFamily="49" charset="0"/>
+                <a:ea typeface="Menlo" panose="020B0609030804020204" pitchFamily="49" charset="0"/>
+                <a:cs typeface="Menlo" panose="020B0609030804020204" pitchFamily="49" charset="0"/>
               </a:rPr>
               <a:t>      </a:t>
             </a:r>
             <a:r>
               <a:rPr lang="en-GB" dirty="0" err="1">
-                <a:latin typeface="Courier" pitchFamily="2" charset="0"/>
+                <a:latin typeface="Menlo" panose="020B0609030804020204" pitchFamily="49" charset="0"/>
+                <a:ea typeface="Menlo" panose="020B0609030804020204" pitchFamily="49" charset="0"/>
+                <a:cs typeface="Menlo" panose="020B0609030804020204" pitchFamily="49" charset="0"/>
               </a:rPr>
               <a:t>appBar</a:t>
             </a:r>
             <a:r>
               <a:rPr lang="en-GB" dirty="0">
-                <a:latin typeface="Courier" pitchFamily="2" charset="0"/>
+                <a:latin typeface="Menlo" panose="020B0609030804020204" pitchFamily="49" charset="0"/>
+                <a:ea typeface="Menlo" panose="020B0609030804020204" pitchFamily="49" charset="0"/>
+                <a:cs typeface="Menlo" panose="020B0609030804020204" pitchFamily="49" charset="0"/>
               </a:rPr>
               <a:t>: </a:t>
             </a:r>
             <a:r>
               <a:rPr lang="en-GB" dirty="0" err="1">
-                <a:latin typeface="Courier" pitchFamily="2" charset="0"/>
+                <a:latin typeface="Menlo" panose="020B0609030804020204" pitchFamily="49" charset="0"/>
+                <a:ea typeface="Menlo" panose="020B0609030804020204" pitchFamily="49" charset="0"/>
+                <a:cs typeface="Menlo" panose="020B0609030804020204" pitchFamily="49" charset="0"/>
               </a:rPr>
               <a:t>AppBar</a:t>
             </a:r>
             <a:r>
               <a:rPr lang="en-GB" dirty="0">
-                <a:latin typeface="Courier" pitchFamily="2" charset="0"/>
+                <a:latin typeface="Menlo" panose="020B0609030804020204" pitchFamily="49" charset="0"/>
+                <a:ea typeface="Menlo" panose="020B0609030804020204" pitchFamily="49" charset="0"/>
+                <a:cs typeface="Menlo" panose="020B0609030804020204" pitchFamily="49" charset="0"/>
               </a:rPr>
               <a:t>(title: Text('Welcome to Flutter'),),</a:t>
             </a:r>
@@ -15842,19 +16525,25 @@
           <a:p>
             <a:r>
               <a:rPr lang="en-GB" dirty="0">
-                <a:latin typeface="Courier" pitchFamily="2" charset="0"/>
+                <a:latin typeface="Menlo" panose="020B0609030804020204" pitchFamily="49" charset="0"/>
+                <a:ea typeface="Menlo" panose="020B0609030804020204" pitchFamily="49" charset="0"/>
+                <a:cs typeface="Menlo" panose="020B0609030804020204" pitchFamily="49" charset="0"/>
               </a:rPr>
               <a:t>      body: </a:t>
             </a:r>
             <a:r>
               <a:rPr lang="en-GB" dirty="0" err="1">
-                <a:latin typeface="Courier" pitchFamily="2" charset="0"/>
+                <a:latin typeface="Menlo" panose="020B0609030804020204" pitchFamily="49" charset="0"/>
+                <a:ea typeface="Menlo" panose="020B0609030804020204" pitchFamily="49" charset="0"/>
+                <a:cs typeface="Menlo" panose="020B0609030804020204" pitchFamily="49" charset="0"/>
               </a:rPr>
               <a:t>Center</a:t>
             </a:r>
             <a:r>
               <a:rPr lang="en-GB" dirty="0">
-                <a:latin typeface="Courier" pitchFamily="2" charset="0"/>
+                <a:latin typeface="Menlo" panose="020B0609030804020204" pitchFamily="49" charset="0"/>
+                <a:ea typeface="Menlo" panose="020B0609030804020204" pitchFamily="49" charset="0"/>
+                <a:cs typeface="Menlo" panose="020B0609030804020204" pitchFamily="49" charset="0"/>
               </a:rPr>
               <a:t>(child: Text('Hello World'),),),</a:t>
             </a:r>
@@ -15862,7 +16551,9 @@
           <a:p>
             <a:r>
               <a:rPr lang="en-GB" dirty="0">
-                <a:latin typeface="Courier" pitchFamily="2" charset="0"/>
+                <a:latin typeface="Menlo" panose="020B0609030804020204" pitchFamily="49" charset="0"/>
+                <a:ea typeface="Menlo" panose="020B0609030804020204" pitchFamily="49" charset="0"/>
+                <a:cs typeface="Menlo" panose="020B0609030804020204" pitchFamily="49" charset="0"/>
               </a:rPr>
               <a:t>    );</a:t>
             </a:r>
@@ -15870,7 +16561,9 @@
           <a:p>
             <a:r>
               <a:rPr lang="en-GB" dirty="0">
-                <a:latin typeface="Courier" pitchFamily="2" charset="0"/>
+                <a:latin typeface="Menlo" panose="020B0609030804020204" pitchFamily="49" charset="0"/>
+                <a:ea typeface="Menlo" panose="020B0609030804020204" pitchFamily="49" charset="0"/>
+                <a:cs typeface="Menlo" panose="020B0609030804020204" pitchFamily="49" charset="0"/>
               </a:rPr>
               <a:t>  }//build</a:t>
             </a:r>
@@ -15878,18 +16571,24 @@
           <a:p>
             <a:r>
               <a:rPr lang="en-GB" dirty="0">
-                <a:latin typeface="Courier" pitchFamily="2" charset="0"/>
+                <a:latin typeface="Menlo" panose="020B0609030804020204" pitchFamily="49" charset="0"/>
+                <a:ea typeface="Menlo" panose="020B0609030804020204" pitchFamily="49" charset="0"/>
+                <a:cs typeface="Menlo" panose="020B0609030804020204" pitchFamily="49" charset="0"/>
               </a:rPr>
               <a:t>}//</a:t>
             </a:r>
             <a:r>
               <a:rPr lang="en-GB" dirty="0" err="1">
-                <a:latin typeface="Courier" pitchFamily="2" charset="0"/>
+                <a:latin typeface="Menlo" panose="020B0609030804020204" pitchFamily="49" charset="0"/>
+                <a:ea typeface="Menlo" panose="020B0609030804020204" pitchFamily="49" charset="0"/>
+                <a:cs typeface="Menlo" panose="020B0609030804020204" pitchFamily="49" charset="0"/>
               </a:rPr>
               <a:t>MyApp</a:t>
             </a:r>
             <a:endParaRPr lang="en-GB" dirty="0">
-              <a:latin typeface="Courier" pitchFamily="2" charset="0"/>
+              <a:latin typeface="Menlo" panose="020B0609030804020204" pitchFamily="49" charset="0"/>
+              <a:ea typeface="Menlo" panose="020B0609030804020204" pitchFamily="49" charset="0"/>
+              <a:cs typeface="Menlo" panose="020B0609030804020204" pitchFamily="49" charset="0"/>
             </a:endParaRPr>
           </a:p>
         </p:txBody>
@@ -16454,7 +17153,9 @@
             </a:pPr>
             <a:r>
               <a:rPr lang="en-GB" dirty="0">
-                <a:latin typeface="Courier" pitchFamily="2" charset="0"/>
+                <a:latin typeface="Menlo" panose="020B0609030804020204" pitchFamily="49" charset="0"/>
+                <a:ea typeface="Menlo" panose="020B0609030804020204" pitchFamily="49" charset="0"/>
+                <a:cs typeface="Menlo" panose="020B0609030804020204" pitchFamily="49" charset="0"/>
               </a:rPr>
               <a:t>‘Hello World’</a:t>
             </a:r>
@@ -16474,7 +17175,9 @@
             </a:pPr>
             <a:r>
               <a:rPr lang="en-GB" dirty="0">
-                <a:latin typeface="Courier" pitchFamily="2" charset="0"/>
+                <a:latin typeface="Menlo" panose="020B0609030804020204" pitchFamily="49" charset="0"/>
+                <a:ea typeface="Menlo" panose="020B0609030804020204" pitchFamily="49" charset="0"/>
+                <a:cs typeface="Menlo" panose="020B0609030804020204" pitchFamily="49" charset="0"/>
               </a:rPr>
               <a:t>‘Hello, Flutter!’</a:t>
             </a:r>

</xml_diff>